<commit_message>
pitch: business-model slide — per-seat SaaS, every employee is a seat
Reframe the business model around universal adoption: a mirror for every
employee, not a dashboard for a few managers. Add per-opted-in-employee
COGS, modeled gross margin, and volume-based scaling, with a footnote
noting the figures are modeled. Rebuild PPTX and PDF from source.
</commit_message>
<xml_diff>
--- a/prototype/pitch/SugApp_Investor_Brief.pptx
+++ b/prototype/pitch/SugApp_Investor_Brief.pptx
@@ -3095,7 +3095,7 @@
               <a:buNone/>
             </a:pPr>
             <a:r>
-              <a:rPr lang="en-US" sz="3300" b="1" dirty="0">
+              <a:rPr lang="en-US" sz="3000" b="1" dirty="0">
                 <a:solidFill>
                   <a:srgbClr val="12312F"/>
                 </a:solidFill>
@@ -3103,26 +3103,136 @@
                 <a:ea typeface="Cambria" pitchFamily="34" charset="-122"/>
                 <a:cs typeface="Cambria" pitchFamily="34" charset="-120"/>
               </a:rPr>
-              <a:t>Per-seat SaaS, priced to the value of retention.</a:t>
-            </a:r>
-            <a:endParaRPr lang="en-US" sz="3300" dirty="0"/>
-          </a:p>
-        </p:txBody>
-      </p:sp>
-      <p:sp>
-        <p:nvSpPr>
-          <p:cNvPr id="4" name="Shape 2"/>
-          <p:cNvSpPr/>
-          <p:nvPr/>
-        </p:nvSpPr>
-        <p:spPr>
-          <a:xfrm>
-            <a:off x="640080" y="2286000"/>
-            <a:ext cx="3392424" cy="3108960"/>
+              <a:t>Per-seat SaaS — and every employee is a seat.</a:t>
+            </a:r>
+            <a:endParaRPr lang="en-US" sz="3000" dirty="0"/>
+          </a:p>
+        </p:txBody>
+      </p:sp>
+      <p:sp>
+        <p:nvSpPr>
+          <p:cNvPr id="4" name="Text 2"/>
+          <p:cNvSpPr/>
+          <p:nvPr/>
+        </p:nvSpPr>
+        <p:spPr>
+          <a:xfrm>
+            <a:off x="640080" y="1572768"/>
+            <a:ext cx="10908792" cy="685800"/>
+          </a:xfrm>
+          <a:prstGeom prst="rect">
+            <a:avLst/>
+          </a:prstGeom>
+          <a:noFill/>
+          <a:ln/>
+        </p:spPr>
+        <p:txBody>
+          <a:bodyPr wrap="square" rtlCol="0" anchor="ctr"/>
+          <a:lstStyle/>
+          <a:p>
+            <a:pPr indent="0" marL="0">
+              <a:lnSpc>
+                <a:spcPct val="110000"/>
+              </a:lnSpc>
+              <a:buNone/>
+            </a:pPr>
+            <a:r>
+              <a:rPr lang="en-US" sz="1450" dirty="0">
+                <a:solidFill>
+                  <a:srgbClr val="12312F"/>
+                </a:solidFill>
+                <a:latin typeface="Calibri" pitchFamily="34" charset="0"/>
+                <a:ea typeface="Calibri" pitchFamily="34" charset="-122"/>
+                <a:cs typeface="Calibri" pitchFamily="34" charset="-120"/>
+              </a:rPr>
+              <a:t>A mirror for </a:t>
+            </a:r>
+            <a:pPr indent="0" marL="0">
+              <a:lnSpc>
+                <a:spcPct val="110000"/>
+              </a:lnSpc>
+              <a:buNone/>
+            </a:pPr>
+            <a:r>
+              <a:rPr lang="en-US" sz="1450" i="1" dirty="0">
+                <a:solidFill>
+                  <a:srgbClr val="12312F"/>
+                </a:solidFill>
+                <a:latin typeface="Calibri" pitchFamily="34" charset="0"/>
+                <a:ea typeface="Calibri" pitchFamily="34" charset="-122"/>
+                <a:cs typeface="Calibri" pitchFamily="34" charset="-120"/>
+              </a:rPr>
+              <a:t>everyone</a:t>
+            </a:r>
+            <a:pPr indent="0" marL="0">
+              <a:lnSpc>
+                <a:spcPct val="110000"/>
+              </a:lnSpc>
+              <a:buNone/>
+            </a:pPr>
+            <a:r>
+              <a:rPr lang="en-US" sz="1450" dirty="0">
+                <a:solidFill>
+                  <a:srgbClr val="12312F"/>
+                </a:solidFill>
+                <a:latin typeface="Calibri" pitchFamily="34" charset="0"/>
+                <a:ea typeface="Calibri" pitchFamily="34" charset="-122"/>
+                <a:cs typeface="Calibri" pitchFamily="34" charset="-120"/>
+              </a:rPr>
+              <a:t>, not a dashboard for a few managers — whole-company adoption, priced per seat. The cost to serve stays tiny because it scales with </a:t>
+            </a:r>
+            <a:pPr indent="0" marL="0">
+              <a:lnSpc>
+                <a:spcPct val="110000"/>
+              </a:lnSpc>
+              <a:buNone/>
+            </a:pPr>
+            <a:r>
+              <a:rPr lang="en-US" sz="1450" b="1" dirty="0">
+                <a:solidFill>
+                  <a:srgbClr val="12312F"/>
+                </a:solidFill>
+                <a:latin typeface="Calibri" pitchFamily="34" charset="0"/>
+                <a:ea typeface="Calibri" pitchFamily="34" charset="-122"/>
+                <a:cs typeface="Calibri" pitchFamily="34" charset="-120"/>
+              </a:rPr>
+              <a:t>message volume, not headcount</a:t>
+            </a:r>
+            <a:pPr indent="0" marL="0">
+              <a:lnSpc>
+                <a:spcPct val="110000"/>
+              </a:lnSpc>
+              <a:buNone/>
+            </a:pPr>
+            <a:r>
+              <a:rPr lang="en-US" sz="1450" dirty="0">
+                <a:solidFill>
+                  <a:srgbClr val="12312F"/>
+                </a:solidFill>
+                <a:latin typeface="Calibri" pitchFamily="34" charset="0"/>
+                <a:ea typeface="Calibri" pitchFamily="34" charset="-122"/>
+                <a:cs typeface="Calibri" pitchFamily="34" charset="-120"/>
+              </a:rPr>
+              <a:t>.</a:t>
+            </a:r>
+            <a:endParaRPr lang="en-US" sz="1450" dirty="0"/>
+          </a:p>
+        </p:txBody>
+      </p:sp>
+      <p:sp>
+        <p:nvSpPr>
+          <p:cNvPr id="5" name="Shape 3"/>
+          <p:cNvSpPr/>
+          <p:nvPr/>
+        </p:nvSpPr>
+        <p:spPr>
+          <a:xfrm>
+            <a:off x="640080" y="2423160"/>
+            <a:ext cx="3392424" cy="1371600"/>
           </a:xfrm>
           <a:prstGeom prst="roundRect">
             <a:avLst>
-              <a:gd name="adj" fmla="val 3235"/>
+              <a:gd name="adj" fmla="val 7333"/>
             </a:avLst>
           </a:prstGeom>
           <a:solidFill>
@@ -3145,60 +3255,43 @@
       </p:sp>
       <p:sp>
         <p:nvSpPr>
-          <p:cNvPr id="5" name="Shape 3"/>
-          <p:cNvSpPr/>
-          <p:nvPr/>
-        </p:nvSpPr>
-        <p:spPr>
-          <a:xfrm>
-            <a:off x="960120" y="2606040"/>
-            <a:ext cx="457200" cy="457200"/>
-          </a:xfrm>
-          <a:prstGeom prst="ellipse">
-            <a:avLst/>
-          </a:prstGeom>
-          <a:solidFill>
-            <a:srgbClr val="1C8D69"/>
-          </a:solidFill>
-          <a:ln/>
-        </p:spPr>
-      </p:sp>
-      <p:sp>
-        <p:nvSpPr>
           <p:cNvPr id="6" name="Text 4"/>
           <p:cNvSpPr/>
           <p:nvPr/>
         </p:nvSpPr>
         <p:spPr>
           <a:xfrm>
-            <a:off x="960120" y="2606040"/>
-            <a:ext cx="457200" cy="457200"/>
-          </a:xfrm>
-          <a:prstGeom prst="rect">
-            <a:avLst/>
-          </a:prstGeom>
-          <a:noFill/>
-          <a:ln/>
-        </p:spPr>
-        <p:txBody>
-          <a:bodyPr wrap="square" rtlCol="0" anchor="ctr"/>
-          <a:lstStyle/>
-          <a:p>
-            <a:pPr algn="ctr" indent="0" marL="0">
-              <a:buNone/>
-            </a:pPr>
-            <a:r>
-              <a:rPr lang="en-US" sz="1800" b="1" dirty="0">
-                <a:solidFill>
-                  <a:srgbClr val="FFFFFF"/>
-                </a:solidFill>
-                <a:latin typeface="Cambria" pitchFamily="34" charset="0"/>
-                <a:ea typeface="Cambria" pitchFamily="34" charset="-122"/>
-                <a:cs typeface="Cambria" pitchFamily="34" charset="-120"/>
-              </a:rPr>
-              <a:t>1</a:t>
-            </a:r>
-            <a:endParaRPr lang="en-US" sz="1800" dirty="0"/>
+            <a:off x="896112" y="2606040"/>
+            <a:ext cx="2880360" cy="502920"/>
+          </a:xfrm>
+          <a:prstGeom prst="rect">
+            <a:avLst/>
+          </a:prstGeom>
+          <a:noFill/>
+          <a:ln/>
+        </p:spPr>
+        <p:txBody>
+          <a:bodyPr wrap="square" rtlCol="0" anchor="ctr"/>
+          <a:lstStyle/>
+          <a:p>
+            <a:pPr indent="0" marL="0">
+              <a:lnSpc>
+                <a:spcPct val="95000"/>
+              </a:lnSpc>
+              <a:buNone/>
+            </a:pPr>
+            <a:r>
+              <a:rPr lang="en-US" sz="1500" b="1" dirty="0">
+                <a:solidFill>
+                  <a:srgbClr val="12312F"/>
+                </a:solidFill>
+                <a:latin typeface="Calibri" pitchFamily="34" charset="0"/>
+                <a:ea typeface="Calibri" pitchFamily="34" charset="-122"/>
+                <a:cs typeface="Calibri" pitchFamily="34" charset="-120"/>
+              </a:rPr>
+              <a:t>Recurring</a:t>
+            </a:r>
+            <a:endParaRPr lang="en-US" sz="1500" dirty="0"/>
           </a:p>
         </p:txBody>
       </p:sp>
@@ -3210,8 +3303,8 @@
         </p:nvSpPr>
         <p:spPr>
           <a:xfrm>
-            <a:off x="960120" y="3246120"/>
-            <a:ext cx="2752344" cy="685800"/>
+            <a:off x="896112" y="3108960"/>
+            <a:ext cx="2880360" cy="594360"/>
           </a:xfrm>
           <a:prstGeom prst="rect">
             <a:avLst/>
@@ -3225,54 +3318,12 @@
           <a:p>
             <a:pPr indent="0" marL="0">
               <a:lnSpc>
-                <a:spcPct val="98000"/>
-              </a:lnSpc>
-              <a:buNone/>
-            </a:pPr>
-            <a:r>
-              <a:rPr lang="en-US" sz="1650" b="1" dirty="0">
-                <a:solidFill>
-                  <a:srgbClr val="12312F"/>
-                </a:solidFill>
-                <a:latin typeface="Calibri" pitchFamily="34" charset="0"/>
-                <a:ea typeface="Calibri" pitchFamily="34" charset="-122"/>
-                <a:cs typeface="Calibri" pitchFamily="34" charset="-120"/>
-              </a:rPr>
-              <a:t>Recurring</a:t>
-            </a:r>
-            <a:endParaRPr lang="en-US" sz="1650" dirty="0"/>
-          </a:p>
-        </p:txBody>
-      </p:sp>
-      <p:sp>
-        <p:nvSpPr>
-          <p:cNvPr id="8" name="Text 6"/>
-          <p:cNvSpPr/>
-          <p:nvPr/>
-        </p:nvSpPr>
-        <p:spPr>
-          <a:xfrm>
-            <a:off x="960120" y="3977640"/>
-            <a:ext cx="2752344" cy="1280160"/>
-          </a:xfrm>
-          <a:prstGeom prst="rect">
-            <a:avLst/>
-          </a:prstGeom>
-          <a:noFill/>
-          <a:ln/>
-        </p:spPr>
-        <p:txBody>
-          <a:bodyPr wrap="square" rtlCol="0" anchor="ctr"/>
-          <a:lstStyle/>
-          <a:p>
-            <a:pPr indent="0" marL="0">
-              <a:lnSpc>
-                <a:spcPct val="108000"/>
-              </a:lnSpc>
-              <a:buNone/>
-            </a:pPr>
-            <a:r>
-              <a:rPr lang="en-US" sz="1350" dirty="0">
+                <a:spcPct val="103000"/>
+              </a:lnSpc>
+              <a:buNone/>
+            </a:pPr>
+            <a:r>
+              <a:rPr lang="en-US" sz="1250" dirty="0">
                 <a:solidFill>
                   <a:srgbClr val="5A716C"/>
                 </a:solidFill>
@@ -3282,24 +3333,24 @@
               </a:rPr>
               <a:t>Per-active-participant monthly subscription; annual contracts at the org tier.</a:t>
             </a:r>
-            <a:endParaRPr lang="en-US" sz="1350" dirty="0"/>
-          </a:p>
-        </p:txBody>
-      </p:sp>
-      <p:sp>
-        <p:nvSpPr>
-          <p:cNvPr id="9" name="Shape 7"/>
-          <p:cNvSpPr/>
-          <p:nvPr/>
-        </p:nvSpPr>
-        <p:spPr>
-          <a:xfrm>
-            <a:off x="4398264" y="2286000"/>
-            <a:ext cx="3392424" cy="3108960"/>
+            <a:endParaRPr lang="en-US" sz="1250" dirty="0"/>
+          </a:p>
+        </p:txBody>
+      </p:sp>
+      <p:sp>
+        <p:nvSpPr>
+          <p:cNvPr id="8" name="Shape 6"/>
+          <p:cNvSpPr/>
+          <p:nvPr/>
+        </p:nvSpPr>
+        <p:spPr>
+          <a:xfrm>
+            <a:off x="4398264" y="2423160"/>
+            <a:ext cx="3392424" cy="1371600"/>
           </a:xfrm>
           <a:prstGeom prst="roundRect">
             <a:avLst>
-              <a:gd name="adj" fmla="val 3235"/>
+              <a:gd name="adj" fmla="val 7333"/>
             </a:avLst>
           </a:prstGeom>
           <a:solidFill>
@@ -3322,73 +3373,14 @@
       </p:sp>
       <p:sp>
         <p:nvSpPr>
-          <p:cNvPr id="10" name="Shape 8"/>
-          <p:cNvSpPr/>
-          <p:nvPr/>
-        </p:nvSpPr>
-        <p:spPr>
-          <a:xfrm>
-            <a:off x="4718304" y="2606040"/>
-            <a:ext cx="457200" cy="457200"/>
-          </a:xfrm>
-          <a:prstGeom prst="ellipse">
-            <a:avLst/>
-          </a:prstGeom>
-          <a:solidFill>
-            <a:srgbClr val="1C8D69"/>
-          </a:solidFill>
-          <a:ln/>
-        </p:spPr>
-      </p:sp>
-      <p:sp>
-        <p:nvSpPr>
-          <p:cNvPr id="11" name="Text 9"/>
-          <p:cNvSpPr/>
-          <p:nvPr/>
-        </p:nvSpPr>
-        <p:spPr>
-          <a:xfrm>
-            <a:off x="4718304" y="2606040"/>
-            <a:ext cx="457200" cy="457200"/>
-          </a:xfrm>
-          <a:prstGeom prst="rect">
-            <a:avLst/>
-          </a:prstGeom>
-          <a:noFill/>
-          <a:ln/>
-        </p:spPr>
-        <p:txBody>
-          <a:bodyPr wrap="square" rtlCol="0" anchor="ctr"/>
-          <a:lstStyle/>
-          <a:p>
-            <a:pPr algn="ctr" indent="0" marL="0">
-              <a:buNone/>
-            </a:pPr>
-            <a:r>
-              <a:rPr lang="en-US" sz="1800" b="1" dirty="0">
-                <a:solidFill>
-                  <a:srgbClr val="FFFFFF"/>
-                </a:solidFill>
-                <a:latin typeface="Cambria" pitchFamily="34" charset="0"/>
-                <a:ea typeface="Cambria" pitchFamily="34" charset="-122"/>
-                <a:cs typeface="Cambria" pitchFamily="34" charset="-120"/>
-              </a:rPr>
-              <a:t>2</a:t>
-            </a:r>
-            <a:endParaRPr lang="en-US" sz="1800" dirty="0"/>
-          </a:p>
-        </p:txBody>
-      </p:sp>
-      <p:sp>
-        <p:nvSpPr>
-          <p:cNvPr id="12" name="Text 10"/>
-          <p:cNvSpPr/>
-          <p:nvPr/>
-        </p:nvSpPr>
-        <p:spPr>
-          <a:xfrm>
-            <a:off x="4718304" y="3246120"/>
-            <a:ext cx="2752344" cy="685800"/>
+          <p:cNvPr id="9" name="Text 7"/>
+          <p:cNvSpPr/>
+          <p:nvPr/>
+        </p:nvSpPr>
+        <p:spPr>
+          <a:xfrm>
+            <a:off x="4654296" y="2606040"/>
+            <a:ext cx="2880360" cy="502920"/>
           </a:xfrm>
           <a:prstGeom prst="rect">
             <a:avLst/>
@@ -3402,12 +3394,12 @@
           <a:p>
             <a:pPr indent="0" marL="0">
               <a:lnSpc>
-                <a:spcPct val="98000"/>
-              </a:lnSpc>
-              <a:buNone/>
-            </a:pPr>
-            <a:r>
-              <a:rPr lang="en-US" sz="1650" b="1" dirty="0">
+                <a:spcPct val="95000"/>
+              </a:lnSpc>
+              <a:buNone/>
+            </a:pPr>
+            <a:r>
+              <a:rPr lang="en-US" sz="1500" b="1" dirty="0">
                 <a:solidFill>
                   <a:srgbClr val="12312F"/>
                 </a:solidFill>
@@ -3415,22 +3407,22 @@
                 <a:ea typeface="Calibri" pitchFamily="34" charset="-122"/>
                 <a:cs typeface="Calibri" pitchFamily="34" charset="-120"/>
               </a:rPr>
-              <a:t>Expansion built in</a:t>
-            </a:r>
-            <a:endParaRPr lang="en-US" sz="1650" dirty="0"/>
-          </a:p>
-        </p:txBody>
-      </p:sp>
-      <p:sp>
-        <p:nvSpPr>
-          <p:cNvPr id="13" name="Text 11"/>
-          <p:cNvSpPr/>
-          <p:nvPr/>
-        </p:nvSpPr>
-        <p:spPr>
-          <a:xfrm>
-            <a:off x="4718304" y="3977640"/>
-            <a:ext cx="2752344" cy="1280160"/>
+              <a:t>Every seat, margin-accretive</a:t>
+            </a:r>
+            <a:endParaRPr lang="en-US" sz="1500" dirty="0"/>
+          </a:p>
+        </p:txBody>
+      </p:sp>
+      <p:sp>
+        <p:nvSpPr>
+          <p:cNvPr id="10" name="Text 8"/>
+          <p:cNvSpPr/>
+          <p:nvPr/>
+        </p:nvSpPr>
+        <p:spPr>
+          <a:xfrm>
+            <a:off x="4654296" y="3108960"/>
+            <a:ext cx="2880360" cy="594360"/>
           </a:xfrm>
           <a:prstGeom prst="rect">
             <a:avLst/>
@@ -3444,12 +3436,12 @@
           <a:p>
             <a:pPr indent="0" marL="0">
               <a:lnSpc>
-                <a:spcPct val="108000"/>
-              </a:lnSpc>
-              <a:buNone/>
-            </a:pPr>
-            <a:r>
-              <a:rPr lang="en-US" sz="1350" dirty="0">
+                <a:spcPct val="103000"/>
+              </a:lnSpc>
+              <a:buNone/>
+            </a:pPr>
+            <a:r>
+              <a:rPr lang="en-US" sz="1250" dirty="0">
                 <a:solidFill>
                   <a:srgbClr val="5A716C"/>
                 </a:solidFill>
@@ -3457,26 +3449,26 @@
                 <a:ea typeface="Calibri" pitchFamily="34" charset="-122"/>
                 <a:cs typeface="Calibri" pitchFamily="34" charset="-120"/>
               </a:rPr>
-              <a:t>Land one team, expand by channel and headcount — net revenue retention is the growth engine.</a:t>
-            </a:r>
-            <a:endParaRPr lang="en-US" sz="1350" dirty="0"/>
-          </a:p>
-        </p:txBody>
-      </p:sp>
-      <p:sp>
-        <p:nvSpPr>
-          <p:cNvPr id="14" name="Shape 12"/>
-          <p:cNvSpPr/>
-          <p:nvPr/>
-        </p:nvSpPr>
-        <p:spPr>
-          <a:xfrm>
-            <a:off x="8156448" y="2286000"/>
-            <a:ext cx="3392424" cy="3108960"/>
+              <a:t>Universal adoption, not power-users; each new seat adds far more revenue than cost.</a:t>
+            </a:r>
+            <a:endParaRPr lang="en-US" sz="1250" dirty="0"/>
+          </a:p>
+        </p:txBody>
+      </p:sp>
+      <p:sp>
+        <p:nvSpPr>
+          <p:cNvPr id="11" name="Shape 9"/>
+          <p:cNvSpPr/>
+          <p:nvPr/>
+        </p:nvSpPr>
+        <p:spPr>
+          <a:xfrm>
+            <a:off x="8156448" y="2423160"/>
+            <a:ext cx="3392424" cy="1371600"/>
           </a:xfrm>
           <a:prstGeom prst="roundRect">
             <a:avLst>
-              <a:gd name="adj" fmla="val 3235"/>
+              <a:gd name="adj" fmla="val 7333"/>
             </a:avLst>
           </a:prstGeom>
           <a:solidFill>
@@ -3499,73 +3491,171 @@
       </p:sp>
       <p:sp>
         <p:nvSpPr>
-          <p:cNvPr id="15" name="Shape 13"/>
-          <p:cNvSpPr/>
-          <p:nvPr/>
-        </p:nvSpPr>
-        <p:spPr>
-          <a:xfrm>
-            <a:off x="8476488" y="2606040"/>
-            <a:ext cx="457200" cy="457200"/>
-          </a:xfrm>
-          <a:prstGeom prst="ellipse">
-            <a:avLst/>
+          <p:cNvPr id="12" name="Text 10"/>
+          <p:cNvSpPr/>
+          <p:nvPr/>
+        </p:nvSpPr>
+        <p:spPr>
+          <a:xfrm>
+            <a:off x="8412480" y="2606040"/>
+            <a:ext cx="2880360" cy="502920"/>
+          </a:xfrm>
+          <a:prstGeom prst="rect">
+            <a:avLst/>
+          </a:prstGeom>
+          <a:noFill/>
+          <a:ln/>
+        </p:spPr>
+        <p:txBody>
+          <a:bodyPr wrap="square" rtlCol="0" anchor="ctr"/>
+          <a:lstStyle/>
+          <a:p>
+            <a:pPr indent="0" marL="0">
+              <a:lnSpc>
+                <a:spcPct val="95000"/>
+              </a:lnSpc>
+              <a:buNone/>
+            </a:pPr>
+            <a:r>
+              <a:rPr lang="en-US" sz="1500" b="1" dirty="0">
+                <a:solidFill>
+                  <a:srgbClr val="12312F"/>
+                </a:solidFill>
+                <a:latin typeface="Calibri" pitchFamily="34" charset="0"/>
+                <a:ea typeface="Calibri" pitchFamily="34" charset="-122"/>
+                <a:cs typeface="Calibri" pitchFamily="34" charset="-120"/>
+              </a:rPr>
+              <a:t>Defensible margin</a:t>
+            </a:r>
+            <a:endParaRPr lang="en-US" sz="1500" dirty="0"/>
+          </a:p>
+        </p:txBody>
+      </p:sp>
+      <p:sp>
+        <p:nvSpPr>
+          <p:cNvPr id="13" name="Text 11"/>
+          <p:cNvSpPr/>
+          <p:nvPr/>
+        </p:nvSpPr>
+        <p:spPr>
+          <a:xfrm>
+            <a:off x="8412480" y="3108960"/>
+            <a:ext cx="2880360" cy="594360"/>
+          </a:xfrm>
+          <a:prstGeom prst="rect">
+            <a:avLst/>
+          </a:prstGeom>
+          <a:noFill/>
+          <a:ln/>
+        </p:spPr>
+        <p:txBody>
+          <a:bodyPr wrap="square" rtlCol="0" anchor="ctr"/>
+          <a:lstStyle/>
+          <a:p>
+            <a:pPr indent="0" marL="0">
+              <a:lnSpc>
+                <a:spcPct val="103000"/>
+              </a:lnSpc>
+              <a:buNone/>
+            </a:pPr>
+            <a:r>
+              <a:rPr lang="en-US" sz="1250" dirty="0">
+                <a:solidFill>
+                  <a:srgbClr val="5A716C"/>
+                </a:solidFill>
+                <a:latin typeface="Calibri" pitchFamily="34" charset="0"/>
+                <a:ea typeface="Calibri" pitchFamily="34" charset="-122"/>
+                <a:cs typeface="Calibri" pitchFamily="34" charset="-120"/>
+              </a:rPr>
+              <a:t>Cost scales with scored volume; the taxonomy and trust posture are the durable moat.</a:t>
+            </a:r>
+            <a:endParaRPr lang="en-US" sz="1250" dirty="0"/>
+          </a:p>
+        </p:txBody>
+      </p:sp>
+      <p:sp>
+        <p:nvSpPr>
+          <p:cNvPr id="14" name="Shape 12"/>
+          <p:cNvSpPr/>
+          <p:nvPr/>
+        </p:nvSpPr>
+        <p:spPr>
+          <a:xfrm>
+            <a:off x="640080" y="4023360"/>
+            <a:ext cx="3392424" cy="1371600"/>
+          </a:xfrm>
+          <a:prstGeom prst="roundRect">
+            <a:avLst>
+              <a:gd name="adj" fmla="val 7333"/>
+            </a:avLst>
           </a:prstGeom>
           <a:solidFill>
-            <a:srgbClr val="1C8D69"/>
+            <a:srgbClr val="FFFFFF"/>
           </a:solidFill>
-          <a:ln/>
-        </p:spPr>
-      </p:sp>
-      <p:sp>
-        <p:nvSpPr>
-          <p:cNvPr id="16" name="Text 14"/>
-          <p:cNvSpPr/>
-          <p:nvPr/>
-        </p:nvSpPr>
-        <p:spPr>
-          <a:xfrm>
-            <a:off x="8476488" y="2606040"/>
-            <a:ext cx="457200" cy="457200"/>
-          </a:xfrm>
-          <a:prstGeom prst="rect">
-            <a:avLst/>
-          </a:prstGeom>
-          <a:noFill/>
-          <a:ln/>
-        </p:spPr>
-        <p:txBody>
-          <a:bodyPr wrap="square" rtlCol="0" anchor="ctr"/>
-          <a:lstStyle/>
-          <a:p>
-            <a:pPr algn="ctr" indent="0" marL="0">
-              <a:buNone/>
-            </a:pPr>
-            <a:r>
-              <a:rPr lang="en-US" sz="1800" b="1" dirty="0">
-                <a:solidFill>
-                  <a:srgbClr val="FFFFFF"/>
+          <a:ln w="12700">
+            <a:solidFill>
+              <a:srgbClr val="D2DED9"/>
+            </a:solidFill>
+            <a:prstDash val="solid"/>
+          </a:ln>
+          <a:effectLst>
+            <a:outerShdw sx="100000" sy="100000" kx="0" ky="0" algn="bl" rotWithShape="0" blurRad="114300" dist="38100" dir="5400000">
+              <a:srgbClr val="10312B">
+                <a:alpha val="16000"/>
+              </a:srgbClr>
+            </a:outerShdw>
+          </a:effectLst>
+        </p:spPr>
+      </p:sp>
+      <p:sp>
+        <p:nvSpPr>
+          <p:cNvPr id="15" name="Text 13"/>
+          <p:cNvSpPr/>
+          <p:nvPr/>
+        </p:nvSpPr>
+        <p:spPr>
+          <a:xfrm>
+            <a:off x="896112" y="4206240"/>
+            <a:ext cx="2880360" cy="502920"/>
+          </a:xfrm>
+          <a:prstGeom prst="rect">
+            <a:avLst/>
+          </a:prstGeom>
+          <a:noFill/>
+          <a:ln/>
+        </p:spPr>
+        <p:txBody>
+          <a:bodyPr wrap="square" rtlCol="0" anchor="ctr"/>
+          <a:lstStyle/>
+          <a:p>
+            <a:pPr indent="0" marL="0">
+              <a:buNone/>
+            </a:pPr>
+            <a:r>
+              <a:rPr lang="en-US" sz="3400" b="1" dirty="0">
+                <a:solidFill>
+                  <a:srgbClr val="1C8D69"/>
                 </a:solidFill>
                 <a:latin typeface="Cambria" pitchFamily="34" charset="0"/>
                 <a:ea typeface="Cambria" pitchFamily="34" charset="-122"/>
                 <a:cs typeface="Cambria" pitchFamily="34" charset="-120"/>
               </a:rPr>
-              <a:t>3</a:t>
-            </a:r>
-            <a:endParaRPr lang="en-US" sz="1800" dirty="0"/>
-          </a:p>
-        </p:txBody>
-      </p:sp>
-      <p:sp>
-        <p:nvSpPr>
-          <p:cNvPr id="17" name="Text 15"/>
-          <p:cNvSpPr/>
-          <p:nvPr/>
-        </p:nvSpPr>
-        <p:spPr>
-          <a:xfrm>
-            <a:off x="8476488" y="3246120"/>
-            <a:ext cx="2752344" cy="685800"/>
+              <a:t>≈ $0.30</a:t>
+            </a:r>
+            <a:endParaRPr lang="en-US" sz="3400" dirty="0"/>
+          </a:p>
+        </p:txBody>
+      </p:sp>
+      <p:sp>
+        <p:nvSpPr>
+          <p:cNvPr id="16" name="Text 14"/>
+          <p:cNvSpPr/>
+          <p:nvPr/>
+        </p:nvSpPr>
+        <p:spPr>
+          <a:xfrm>
+            <a:off x="896112" y="4754880"/>
+            <a:ext cx="2880360" cy="548640"/>
           </a:xfrm>
           <a:prstGeom prst="rect">
             <a:avLst/>
@@ -3579,24 +3669,58 @@
           <a:p>
             <a:pPr indent="0" marL="0">
               <a:lnSpc>
-                <a:spcPct val="98000"/>
-              </a:lnSpc>
-              <a:buNone/>
-            </a:pPr>
-            <a:r>
-              <a:rPr lang="en-US" sz="1650" b="1" dirty="0">
-                <a:solidFill>
-                  <a:srgbClr val="12312F"/>
-                </a:solidFill>
-                <a:latin typeface="Calibri" pitchFamily="34" charset="0"/>
-                <a:ea typeface="Calibri" pitchFamily="34" charset="-122"/>
-                <a:cs typeface="Calibri" pitchFamily="34" charset="-120"/>
-              </a:rPr>
-              <a:t>Defensible margin</a:t>
-            </a:r>
-            <a:endParaRPr lang="en-US" sz="1650" dirty="0"/>
-          </a:p>
-        </p:txBody>
+                <a:spcPct val="103000"/>
+              </a:lnSpc>
+              <a:buNone/>
+            </a:pPr>
+            <a:r>
+              <a:rPr lang="en-US" sz="1200" dirty="0">
+                <a:solidFill>
+                  <a:srgbClr val="5A716C"/>
+                </a:solidFill>
+                <a:latin typeface="Calibri" pitchFamily="34" charset="0"/>
+                <a:ea typeface="Calibri" pitchFamily="34" charset="-122"/>
+                <a:cs typeface="Calibri" pitchFamily="34" charset="-120"/>
+              </a:rPr>
+              <a:t>per opted-in employee / month to serve on Sonnet (~$0.10 on Haiku).</a:t>
+            </a:r>
+            <a:endParaRPr lang="en-US" sz="1200" dirty="0"/>
+          </a:p>
+        </p:txBody>
+      </p:sp>
+      <p:sp>
+        <p:nvSpPr>
+          <p:cNvPr id="17" name="Shape 15"/>
+          <p:cNvSpPr/>
+          <p:nvPr/>
+        </p:nvSpPr>
+        <p:spPr>
+          <a:xfrm>
+            <a:off x="4398264" y="4023360"/>
+            <a:ext cx="3392424" cy="1371600"/>
+          </a:xfrm>
+          <a:prstGeom prst="roundRect">
+            <a:avLst>
+              <a:gd name="adj" fmla="val 7333"/>
+            </a:avLst>
+          </a:prstGeom>
+          <a:solidFill>
+            <a:srgbClr val="FFFFFF"/>
+          </a:solidFill>
+          <a:ln w="12700">
+            <a:solidFill>
+              <a:srgbClr val="D2DED9"/>
+            </a:solidFill>
+            <a:prstDash val="solid"/>
+          </a:ln>
+          <a:effectLst>
+            <a:outerShdw sx="100000" sy="100000" kx="0" ky="0" algn="bl" rotWithShape="0" blurRad="114300" dist="38100" dir="5400000">
+              <a:srgbClr val="10312B">
+                <a:alpha val="16000"/>
+              </a:srgbClr>
+            </a:outerShdw>
+          </a:effectLst>
+        </p:spPr>
       </p:sp>
       <p:sp>
         <p:nvSpPr>
@@ -3606,8 +3730,8 @@
         </p:nvSpPr>
         <p:spPr>
           <a:xfrm>
-            <a:off x="8476488" y="3977640"/>
-            <a:ext cx="2752344" cy="1280160"/>
+            <a:off x="4654296" y="4206240"/>
+            <a:ext cx="2880360" cy="502920"/>
           </a:xfrm>
           <a:prstGeom prst="rect">
             <a:avLst/>
@@ -3620,13 +3744,52 @@
           <a:lstStyle/>
           <a:p>
             <a:pPr indent="0" marL="0">
-              <a:lnSpc>
-                <a:spcPct val="108000"/>
-              </a:lnSpc>
-              <a:buNone/>
-            </a:pPr>
-            <a:r>
-              <a:rPr lang="en-US" sz="1350" dirty="0">
+              <a:buNone/>
+            </a:pPr>
+            <a:r>
+              <a:rPr lang="en-US" sz="3400" b="1" dirty="0">
+                <a:solidFill>
+                  <a:srgbClr val="1C8D69"/>
+                </a:solidFill>
+                <a:latin typeface="Cambria" pitchFamily="34" charset="0"/>
+                <a:ea typeface="Cambria" pitchFamily="34" charset="-122"/>
+                <a:cs typeface="Cambria" pitchFamily="34" charset="-120"/>
+              </a:rPr>
+              <a:t>~90%+</a:t>
+            </a:r>
+            <a:endParaRPr lang="en-US" sz="3400" dirty="0"/>
+          </a:p>
+        </p:txBody>
+      </p:sp>
+      <p:sp>
+        <p:nvSpPr>
+          <p:cNvPr id="19" name="Text 17"/>
+          <p:cNvSpPr/>
+          <p:nvPr/>
+        </p:nvSpPr>
+        <p:spPr>
+          <a:xfrm>
+            <a:off x="4654296" y="4754880"/>
+            <a:ext cx="2880360" cy="548640"/>
+          </a:xfrm>
+          <a:prstGeom prst="rect">
+            <a:avLst/>
+          </a:prstGeom>
+          <a:noFill/>
+          <a:ln/>
+        </p:spPr>
+        <p:txBody>
+          <a:bodyPr wrap="square" rtlCol="0" anchor="ctr"/>
+          <a:lstStyle/>
+          <a:p>
+            <a:pPr indent="0" marL="0">
+              <a:lnSpc>
+                <a:spcPct val="103000"/>
+              </a:lnSpc>
+              <a:buNone/>
+            </a:pPr>
+            <a:r>
+              <a:rPr lang="en-US" sz="1200" dirty="0">
                 <a:solidFill>
                   <a:srgbClr val="5A716C"/>
                 </a:solidFill>
@@ -3634,9 +3797,166 @@
                 <a:ea typeface="Calibri" pitchFamily="34" charset="-122"/>
                 <a:cs typeface="Calibri" pitchFamily="34" charset="-120"/>
               </a:rPr>
-              <a:t>Cost scales with scored volume, not seats; the taxonomy and trust posture are the durable moat.</a:t>
-            </a:r>
-            <a:endParaRPr lang="en-US" sz="1350" dirty="0"/>
+              <a:t>modeled gross margin at an illustrative $4 / seat / month.</a:t>
+            </a:r>
+            <a:endParaRPr lang="en-US" sz="1200" dirty="0"/>
+          </a:p>
+        </p:txBody>
+      </p:sp>
+      <p:sp>
+        <p:nvSpPr>
+          <p:cNvPr id="20" name="Shape 18"/>
+          <p:cNvSpPr/>
+          <p:nvPr/>
+        </p:nvSpPr>
+        <p:spPr>
+          <a:xfrm>
+            <a:off x="8156448" y="4023360"/>
+            <a:ext cx="3392424" cy="1371600"/>
+          </a:xfrm>
+          <a:prstGeom prst="roundRect">
+            <a:avLst>
+              <a:gd name="adj" fmla="val 7333"/>
+            </a:avLst>
+          </a:prstGeom>
+          <a:solidFill>
+            <a:srgbClr val="FFFFFF"/>
+          </a:solidFill>
+          <a:ln w="12700">
+            <a:solidFill>
+              <a:srgbClr val="D2DED9"/>
+            </a:solidFill>
+            <a:prstDash val="solid"/>
+          </a:ln>
+          <a:effectLst>
+            <a:outerShdw sx="100000" sy="100000" kx="0" ky="0" algn="bl" rotWithShape="0" blurRad="114300" dist="38100" dir="5400000">
+              <a:srgbClr val="10312B">
+                <a:alpha val="16000"/>
+              </a:srgbClr>
+            </a:outerShdw>
+          </a:effectLst>
+        </p:spPr>
+      </p:sp>
+      <p:sp>
+        <p:nvSpPr>
+          <p:cNvPr id="21" name="Text 19"/>
+          <p:cNvSpPr/>
+          <p:nvPr/>
+        </p:nvSpPr>
+        <p:spPr>
+          <a:xfrm>
+            <a:off x="8412480" y="4206240"/>
+            <a:ext cx="2880360" cy="502920"/>
+          </a:xfrm>
+          <a:prstGeom prst="rect">
+            <a:avLst/>
+          </a:prstGeom>
+          <a:noFill/>
+          <a:ln/>
+        </p:spPr>
+        <p:txBody>
+          <a:bodyPr wrap="square" rtlCol="0" anchor="ctr"/>
+          <a:lstStyle/>
+          <a:p>
+            <a:pPr indent="0" marL="0">
+              <a:buNone/>
+            </a:pPr>
+            <a:r>
+              <a:rPr lang="en-US" sz="2200" b="1" dirty="0">
+                <a:solidFill>
+                  <a:srgbClr val="1C8D69"/>
+                </a:solidFill>
+                <a:latin typeface="Cambria" pitchFamily="34" charset="0"/>
+                <a:ea typeface="Cambria" pitchFamily="34" charset="-122"/>
+                <a:cs typeface="Cambria" pitchFamily="34" charset="-120"/>
+              </a:rPr>
+              <a:t>Volume-based</a:t>
+            </a:r>
+            <a:endParaRPr lang="en-US" sz="2200" dirty="0"/>
+          </a:p>
+        </p:txBody>
+      </p:sp>
+      <p:sp>
+        <p:nvSpPr>
+          <p:cNvPr id="22" name="Text 20"/>
+          <p:cNvSpPr/>
+          <p:nvPr/>
+        </p:nvSpPr>
+        <p:spPr>
+          <a:xfrm>
+            <a:off x="8412480" y="4754880"/>
+            <a:ext cx="2880360" cy="548640"/>
+          </a:xfrm>
+          <a:prstGeom prst="rect">
+            <a:avLst/>
+          </a:prstGeom>
+          <a:noFill/>
+          <a:ln/>
+        </p:spPr>
+        <p:txBody>
+          <a:bodyPr wrap="square" rtlCol="0" anchor="ctr"/>
+          <a:lstStyle/>
+          <a:p>
+            <a:pPr indent="0" marL="0">
+              <a:lnSpc>
+                <a:spcPct val="103000"/>
+              </a:lnSpc>
+              <a:buNone/>
+            </a:pPr>
+            <a:r>
+              <a:rPr lang="en-US" sz="1200" dirty="0">
+                <a:solidFill>
+                  <a:srgbClr val="5A716C"/>
+                </a:solidFill>
+                <a:latin typeface="Calibri" pitchFamily="34" charset="0"/>
+                <a:ea typeface="Calibri" pitchFamily="34" charset="-122"/>
+                <a:cs typeface="Calibri" pitchFamily="34" charset="-120"/>
+              </a:rPr>
+              <a:t>cost tracks messages, not seats — so it holds at 50 or 50,000 people.</a:t>
+            </a:r>
+            <a:endParaRPr lang="en-US" sz="1200" dirty="0"/>
+          </a:p>
+        </p:txBody>
+      </p:sp>
+      <p:sp>
+        <p:nvSpPr>
+          <p:cNvPr id="23" name="Text 21"/>
+          <p:cNvSpPr/>
+          <p:nvPr/>
+        </p:nvSpPr>
+        <p:spPr>
+          <a:xfrm>
+            <a:off x="640080" y="5623560"/>
+            <a:ext cx="10908792" cy="548640"/>
+          </a:xfrm>
+          <a:prstGeom prst="rect">
+            <a:avLst/>
+          </a:prstGeom>
+          <a:noFill/>
+          <a:ln/>
+        </p:spPr>
+        <p:txBody>
+          <a:bodyPr wrap="square" rtlCol="0" anchor="ctr"/>
+          <a:lstStyle/>
+          <a:p>
+            <a:pPr indent="0" marL="0">
+              <a:lnSpc>
+                <a:spcPct val="105000"/>
+              </a:lnSpc>
+              <a:buNone/>
+            </a:pPr>
+            <a:r>
+              <a:rPr lang="en-US" sz="1150" i="1" dirty="0">
+                <a:solidFill>
+                  <a:srgbClr val="5A716C"/>
+                </a:solidFill>
+                <a:latin typeface="Calibri" pitchFamily="34" charset="0"/>
+                <a:ea typeface="Calibri" pitchFamily="34" charset="-122"/>
+                <a:cs typeface="Calibri" pitchFamily="34" charset="-120"/>
+              </a:rPr>
+              <a:t>Modeled from LLM token costs at ~75% opt-in (250-person example ≈ $35–70/mo to serve). Message volume is the main driver; $4/seat is illustrative — replace with your numbers before presenting.</a:t>
+            </a:r>
+            <a:endParaRPr lang="en-US" sz="1150" dirty="0"/>
           </a:p>
         </p:txBody>
       </p:sp>

</xml_diff>

<commit_message>
pitch: set author name to Suguna Mannepalli on deck
Replace the <Your Legal Name> placeholder with Suguna Mannepalli across
the cover byline, copyright footer, and print stamp; rebuild PPTX and PDF.
</commit_message>
<xml_diff>
--- a/prototype/pitch/SugApp_Investor_Brief.pptx
+++ b/prototype/pitch/SugApp_Investor_Brief.pptx
@@ -2360,9 +2360,48 @@
           </a:p>
         </p:txBody>
       </p:sp>
+      <p:sp>
+        <p:nvSpPr>
+          <p:cNvPr id="6" name="Text 4"/>
+          <p:cNvSpPr/>
+          <p:nvPr/>
+        </p:nvSpPr>
+        <p:spPr>
+          <a:xfrm>
+            <a:off x="640080" y="5715000"/>
+            <a:ext cx="5486400" cy="320040"/>
+          </a:xfrm>
+          <a:prstGeom prst="rect">
+            <a:avLst/>
+          </a:prstGeom>
+          <a:noFill/>
+          <a:ln/>
+        </p:spPr>
+        <p:txBody>
+          <a:bodyPr wrap="square" rtlCol="0" anchor="ctr"/>
+          <a:lstStyle/>
+          <a:p>
+            <a:pPr indent="0" marL="0">
+              <a:buNone/>
+            </a:pPr>
+            <a:r>
+              <a:rPr lang="en-US" sz="1350" b="1" dirty="0">
+                <a:solidFill>
+                  <a:srgbClr val="FFFFFF"/>
+                </a:solidFill>
+                <a:latin typeface="Calibri" pitchFamily="34" charset="0"/>
+                <a:ea typeface="Calibri" pitchFamily="34" charset="-122"/>
+                <a:cs typeface="Calibri" pitchFamily="34" charset="-120"/>
+              </a:rPr>
+              <a:t>Prepared by Suguna Mannepalli</a:t>
+            </a:r>
+            <a:endParaRPr lang="en-US" sz="1350" dirty="0"/>
+          </a:p>
+        </p:txBody>
+      </p:sp>
       <p:graphicFrame>
         <p:nvGraphicFramePr>
-          <p:cNvPr id="6" name="Chart 0" descr=""/>
+          <p:cNvPr id="7" name="Chart 0" descr=""/>
           <p:cNvGraphicFramePr/>
           <p:nvPr/>
         </p:nvGraphicFramePr>
@@ -2378,7 +2417,7 @@
       </p:graphicFrame>
       <p:sp>
         <p:nvSpPr>
-          <p:cNvPr id="7" name="Text 4"/>
+          <p:cNvPr id="8" name="Text 5"/>
           <p:cNvSpPr/>
           <p:nvPr/>
         </p:nvSpPr>
@@ -2417,7 +2456,7 @@
       </p:sp>
       <p:sp>
         <p:nvSpPr>
-          <p:cNvPr id="8" name="Text 5"/>
+          <p:cNvPr id="9" name="Text 6"/>
           <p:cNvSpPr/>
           <p:nvPr/>
         </p:nvSpPr>
@@ -2456,7 +2495,7 @@
       </p:sp>
       <p:sp>
         <p:nvSpPr>
-          <p:cNvPr id="9" name="Text 6"/>
+          <p:cNvPr id="10" name="Text 7"/>
           <p:cNvSpPr/>
           <p:nvPr/>
         </p:nvSpPr>
@@ -2495,7 +2534,7 @@
       </p:sp>
       <p:sp>
         <p:nvSpPr>
-          <p:cNvPr id="10" name="Text 7"/>
+          <p:cNvPr id="11" name="Text 8"/>
           <p:cNvSpPr/>
           <p:nvPr/>
         </p:nvSpPr>
@@ -5311,7 +5350,7 @@
                 <a:ea typeface="Calibri" pitchFamily="34" charset="-122"/>
                 <a:cs typeface="Calibri" pitchFamily="34" charset="-120"/>
               </a:rPr>
-              <a:t>SugApp (working name)  ·  © 2026 &lt;Your Legal Name&gt;. All rights reserved.  ·  Confidential &amp; Proprietary — contains trade-secret methodology.</a:t>
+              <a:t>SugApp (working name)  ·  © 2026 Suguna Mannepalli. All rights reserved.  ·  Confidential &amp; Proprietary — contains trade-secret methodology.</a:t>
             </a:r>
             <a:endParaRPr lang="en-US" sz="1000" dirty="0"/>
           </a:p>

</xml_diff>

<commit_message>
pitch: correct program name to Launch Chapel Hill
The deck was addressed to LaunchUNC; the target program is Launch Chapel
Hill. Fix the name on the cover, ask slide, and footer across the HTML,
PPTX generator, and print stylesheet, and rebuild PPTX and PDF.
</commit_message>
<xml_diff>
--- a/prototype/pitch/SugApp_Investor_Brief.pptx
+++ b/prototype/pitch/SugApp_Investor_Brief.pptx
@@ -2565,7 +2565,7 @@
                 <a:ea typeface="Calibri" pitchFamily="34" charset="-122"/>
                 <a:cs typeface="Calibri" pitchFamily="34" charset="-120"/>
               </a:rPr>
-              <a:t>SugApp (working name)  ·  Confidential &amp; Proprietary  ·  Prepared for LaunchUNC</a:t>
+              <a:t>SugApp (working name)  ·  Confidential &amp; Proprietary  ·  Prepared for Launch Chapel Hill</a:t>
             </a:r>
             <a:endParaRPr lang="en-US" sz="1050" dirty="0"/>
           </a:p>
@@ -5005,7 +5005,7 @@
                 <a:ea typeface="Cambria" pitchFamily="34" charset="-122"/>
                 <a:cs typeface="Cambria" pitchFamily="34" charset="-120"/>
               </a:rPr>
-              <a:t>What we want from LaunchUNC.</a:t>
+              <a:t>What we want from Launch Chapel Hill.</a:t>
             </a:r>
             <a:endParaRPr lang="en-US" sz="3400" dirty="0"/>
           </a:p>

</xml_diff>

<commit_message>
pitch: add Founder and Validation slides
Add a Founder slide (Suguna Mannepalli — 20+ yrs corporate IT + accredited
leadership coach) framing the coaching insight that is the product's core
mechanism. Add a Validation slide pairing qualitative discovery with cited
third-party statistics (UKG Workforce Institute, Eurich/HBR, Salesforce).
Renumber the ask, refresh outputs, and update the README outline (15 slides).
</commit_message>
<xml_diff>
--- a/prototype/pitch/SugApp_Investor_Brief.pptx
+++ b/prototype/pitch/SugApp_Investor_Brief.pptx
@@ -18,9 +18,11 @@
     <p:sldId id="266" r:id="rId12"/>
     <p:sldId id="267" r:id="rId13"/>
     <p:sldId id="268" r:id="rId14"/>
+    <p:sldId id="269" r:id="rId15"/>
+    <p:sldId id="270" r:id="rId16"/>
   </p:sldIdLst>
   <p:notesMasterIdLst>
-    <p:notesMasterId r:id="rId15"/>
+    <p:notesMasterId r:id="rId17"/>
   </p:notesMasterIdLst>
   <p:sldSz cx="12192000" cy="6858000"/>
   <p:notesSz cx="6858000" cy="12192000"/>
@@ -1091,6 +1093,182 @@
             <a:fld id="{F7021451-1387-4CA6-816F-3879F97B5CBC}" type="slidenum">
               <a:rPr lang="en-US"/>
               <a:t>13</a:t>
+            </a:fld>
+            <a:endParaRPr lang="en-US"/>
+          </a:p>
+        </p:txBody>
+      </p:sp>
+    </p:spTree>
+    <p:extLst>
+      <p:ext uri="{BB962C8B-B14F-4D97-AF65-F5344CB8AC3E}">
+        <p14:creationId xmlns:p14="http://schemas.microsoft.com/office/powerpoint/2010/main" val="1024086991"/>
+      </p:ext>
+    </p:extLst>
+  </p:cSld>
+  <p:clrMapOvr>
+    <a:masterClrMapping/>
+  </p:clrMapOvr>
+</p:notes>
+</file>
+
+<file path=ppt/notesSlides/notesSlide14.xml><?xml version="1.0" encoding="utf-8"?>
+<p:notes xmlns:a="http://schemas.openxmlformats.org/drawingml/2006/main" xmlns:r="http://schemas.openxmlformats.org/officeDocument/2006/relationships" xmlns:p="http://schemas.openxmlformats.org/presentationml/2006/main">
+  <p:cSld>
+    <p:spTree>
+      <p:nvGrpSpPr>
+        <p:cNvPr id="1" name=""/>
+        <p:cNvGrpSpPr/>
+        <p:nvPr/>
+      </p:nvGrpSpPr>
+      <p:grpSpPr>
+        <a:xfrm>
+          <a:off x="0" y="0"/>
+          <a:ext cx="0" cy="0"/>
+          <a:chOff x="0" y="0"/>
+          <a:chExt cx="0" cy="0"/>
+        </a:xfrm>
+      </p:grpSpPr>
+      <p:sp>
+        <p:nvSpPr>
+          <p:cNvPr id="2" name="Slide Image Placeholder 1"/>
+          <p:cNvSpPr>
+            <a:spLocks noGrp="1" noRot="1" noChangeAspect="1"/>
+          </p:cNvSpPr>
+          <p:nvPr>
+            <p:ph type="sldImg"/>
+          </p:nvPr>
+        </p:nvSpPr>
+        <p:spPr/>
+      </p:sp>
+      <p:sp>
+        <p:nvSpPr>
+          <p:cNvPr id="3" name="Notes Placeholder 2"/>
+          <p:cNvSpPr>
+            <a:spLocks noGrp="1"/>
+          </p:cNvSpPr>
+          <p:nvPr>
+            <p:ph type="body" idx="1"/>
+          </p:nvPr>
+        </p:nvSpPr>
+        <p:spPr/>
+        <p:txBody>
+          <a:bodyPr/>
+          <a:lstStyle/>
+          <a:p>
+            <a:r>
+              <a:rPr lang="en-US" dirty="0"/>
+              <a:t/>
+            </a:r>
+            <a:endParaRPr lang="en-US" dirty="0"/>
+          </a:p>
+        </p:txBody>
+      </p:sp>
+      <p:sp>
+        <p:nvSpPr>
+          <p:cNvPr id="4" name="Slide Number Placeholder 3"/>
+          <p:cNvSpPr>
+            <a:spLocks noGrp="1"/>
+          </p:cNvSpPr>
+          <p:nvPr>
+            <p:ph type="sldNum" sz="quarter" idx="10"/>
+          </p:nvPr>
+        </p:nvSpPr>
+        <p:spPr/>
+        <p:txBody>
+          <a:bodyPr/>
+          <a:lstStyle/>
+          <a:p>
+            <a:fld id="{F7021451-1387-4CA6-816F-3879F97B5CBC}" type="slidenum">
+              <a:rPr lang="en-US"/>
+              <a:t>14</a:t>
+            </a:fld>
+            <a:endParaRPr lang="en-US"/>
+          </a:p>
+        </p:txBody>
+      </p:sp>
+    </p:spTree>
+    <p:extLst>
+      <p:ext uri="{BB962C8B-B14F-4D97-AF65-F5344CB8AC3E}">
+        <p14:creationId xmlns:p14="http://schemas.microsoft.com/office/powerpoint/2010/main" val="1024086991"/>
+      </p:ext>
+    </p:extLst>
+  </p:cSld>
+  <p:clrMapOvr>
+    <a:masterClrMapping/>
+  </p:clrMapOvr>
+</p:notes>
+</file>
+
+<file path=ppt/notesSlides/notesSlide15.xml><?xml version="1.0" encoding="utf-8"?>
+<p:notes xmlns:a="http://schemas.openxmlformats.org/drawingml/2006/main" xmlns:r="http://schemas.openxmlformats.org/officeDocument/2006/relationships" xmlns:p="http://schemas.openxmlformats.org/presentationml/2006/main">
+  <p:cSld>
+    <p:spTree>
+      <p:nvGrpSpPr>
+        <p:cNvPr id="1" name=""/>
+        <p:cNvGrpSpPr/>
+        <p:nvPr/>
+      </p:nvGrpSpPr>
+      <p:grpSpPr>
+        <a:xfrm>
+          <a:off x="0" y="0"/>
+          <a:ext cx="0" cy="0"/>
+          <a:chOff x="0" y="0"/>
+          <a:chExt cx="0" cy="0"/>
+        </a:xfrm>
+      </p:grpSpPr>
+      <p:sp>
+        <p:nvSpPr>
+          <p:cNvPr id="2" name="Slide Image Placeholder 1"/>
+          <p:cNvSpPr>
+            <a:spLocks noGrp="1" noRot="1" noChangeAspect="1"/>
+          </p:cNvSpPr>
+          <p:nvPr>
+            <p:ph type="sldImg"/>
+          </p:nvPr>
+        </p:nvSpPr>
+        <p:spPr/>
+      </p:sp>
+      <p:sp>
+        <p:nvSpPr>
+          <p:cNvPr id="3" name="Notes Placeholder 2"/>
+          <p:cNvSpPr>
+            <a:spLocks noGrp="1"/>
+          </p:cNvSpPr>
+          <p:nvPr>
+            <p:ph type="body" idx="1"/>
+          </p:nvPr>
+        </p:nvSpPr>
+        <p:spPr/>
+        <p:txBody>
+          <a:bodyPr/>
+          <a:lstStyle/>
+          <a:p>
+            <a:r>
+              <a:rPr lang="en-US" dirty="0"/>
+              <a:t/>
+            </a:r>
+            <a:endParaRPr lang="en-US" dirty="0"/>
+          </a:p>
+        </p:txBody>
+      </p:sp>
+      <p:sp>
+        <p:nvSpPr>
+          <p:cNvPr id="4" name="Slide Number Placeholder 3"/>
+          <p:cNvSpPr>
+            <a:spLocks noGrp="1"/>
+          </p:cNvSpPr>
+          <p:nvPr>
+            <p:ph type="sldNum" sz="quarter" idx="10"/>
+          </p:nvPr>
+        </p:nvSpPr>
+        <p:spPr/>
+        <p:txBody>
+          <a:bodyPr/>
+          <a:lstStyle/>
+          <a:p>
+            <a:fld id="{F7021451-1387-4CA6-816F-3879F97B5CBC}" type="slidenum">
+              <a:rPr lang="en-US"/>
+              <a:t>15</a:t>
             </a:fld>
             <a:endParaRPr lang="en-US"/>
           </a:p>
@@ -4912,6 +5090,1137 @@
     <p:bg>
       <p:bgPr>
         <a:solidFill>
+          <a:srgbClr val="FFFFFF"/>
+        </a:solidFill>
+      </p:bgPr>
+    </p:bg>
+    <p:spTree>
+      <p:nvGrpSpPr>
+        <p:cNvPr id="1" name=""/>
+        <p:cNvGrpSpPr/>
+        <p:nvPr/>
+      </p:nvGrpSpPr>
+      <p:grpSpPr>
+        <a:xfrm>
+          <a:off x="0" y="0"/>
+          <a:ext cx="0" cy="0"/>
+          <a:chOff x="0" y="0"/>
+          <a:chExt cx="0" cy="0"/>
+        </a:xfrm>
+      </p:grpSpPr>
+      <p:sp>
+        <p:nvSpPr>
+          <p:cNvPr id="2" name="Text 0"/>
+          <p:cNvSpPr/>
+          <p:nvPr/>
+        </p:nvSpPr>
+        <p:spPr>
+          <a:xfrm>
+            <a:off x="640080" y="502920"/>
+            <a:ext cx="10908792" cy="274320"/>
+          </a:xfrm>
+          <a:prstGeom prst="rect">
+            <a:avLst/>
+          </a:prstGeom>
+          <a:noFill/>
+          <a:ln/>
+        </p:spPr>
+        <p:txBody>
+          <a:bodyPr wrap="square" rtlCol="0" anchor="ctr"/>
+          <a:lstStyle/>
+          <a:p>
+            <a:pPr algn="l" indent="0" marL="0">
+              <a:buNone/>
+            </a:pPr>
+            <a:r>
+              <a:rPr lang="en-US" sz="1150" b="1" spc="300" kern="0" dirty="0">
+                <a:solidFill>
+                  <a:srgbClr val="1C8D69"/>
+                </a:solidFill>
+                <a:latin typeface="Calibri" pitchFamily="34" charset="0"/>
+                <a:ea typeface="Calibri" pitchFamily="34" charset="-122"/>
+                <a:cs typeface="Calibri" pitchFamily="34" charset="-120"/>
+              </a:rPr>
+              <a:t>12 · VALIDATION</a:t>
+            </a:r>
+            <a:endParaRPr lang="en-US" sz="1150" dirty="0"/>
+          </a:p>
+        </p:txBody>
+      </p:sp>
+      <p:sp>
+        <p:nvSpPr>
+          <p:cNvPr id="3" name="Text 1"/>
+          <p:cNvSpPr/>
+          <p:nvPr/>
+        </p:nvSpPr>
+        <p:spPr>
+          <a:xfrm>
+            <a:off x="640080" y="841248"/>
+            <a:ext cx="10908792" cy="914400"/>
+          </a:xfrm>
+          <a:prstGeom prst="rect">
+            <a:avLst/>
+          </a:prstGeom>
+          <a:noFill/>
+          <a:ln/>
+        </p:spPr>
+        <p:txBody>
+          <a:bodyPr wrap="square" rtlCol="0" anchor="ctr"/>
+          <a:lstStyle/>
+          <a:p>
+            <a:pPr algn="l" indent="0" marL="0">
+              <a:lnSpc>
+                <a:spcPct val="98000"/>
+              </a:lnSpc>
+              <a:buNone/>
+            </a:pPr>
+            <a:r>
+              <a:rPr lang="en-US" sz="3300" b="1" dirty="0">
+                <a:solidFill>
+                  <a:srgbClr val="12312F"/>
+                </a:solidFill>
+                <a:latin typeface="Cambria" pitchFamily="34" charset="0"/>
+                <a:ea typeface="Cambria" pitchFamily="34" charset="-122"/>
+                <a:cs typeface="Cambria" pitchFamily="34" charset="-120"/>
+              </a:rPr>
+              <a:t>The pain is real — and people told us so.</a:t>
+            </a:r>
+            <a:endParaRPr lang="en-US" sz="3300" dirty="0"/>
+          </a:p>
+        </p:txBody>
+      </p:sp>
+      <p:sp>
+        <p:nvSpPr>
+          <p:cNvPr id="4" name="Text 2"/>
+          <p:cNvSpPr/>
+          <p:nvPr/>
+        </p:nvSpPr>
+        <p:spPr>
+          <a:xfrm>
+            <a:off x="640080" y="1737360"/>
+            <a:ext cx="10908792" cy="822960"/>
+          </a:xfrm>
+          <a:prstGeom prst="rect">
+            <a:avLst/>
+          </a:prstGeom>
+          <a:noFill/>
+          <a:ln/>
+        </p:spPr>
+        <p:txBody>
+          <a:bodyPr wrap="square" rtlCol="0" anchor="ctr"/>
+          <a:lstStyle/>
+          <a:p>
+            <a:pPr indent="0" marL="0">
+              <a:lnSpc>
+                <a:spcPct val="112000"/>
+              </a:lnSpc>
+              <a:buNone/>
+            </a:pPr>
+            <a:r>
+              <a:rPr lang="en-US" sz="1500" dirty="0">
+                <a:solidFill>
+                  <a:srgbClr val="12312F"/>
+                </a:solidFill>
+                <a:latin typeface="Calibri" pitchFamily="34" charset="0"/>
+                <a:ea typeface="Calibri" pitchFamily="34" charset="-122"/>
+                <a:cs typeface="Calibri" pitchFamily="34" charset="-120"/>
+              </a:rPr>
+              <a:t>In discovery conversations with leaders and individual contributors alike, two themes surfaced again and again: people don’t feel heard, and they’ve never had a structured way to reflect on their own behavior. The published research says the same at scale.</a:t>
+            </a:r>
+            <a:endParaRPr lang="en-US" sz="1500" dirty="0"/>
+          </a:p>
+        </p:txBody>
+      </p:sp>
+      <p:sp>
+        <p:nvSpPr>
+          <p:cNvPr id="5" name="Shape 3"/>
+          <p:cNvSpPr/>
+          <p:nvPr/>
+        </p:nvSpPr>
+        <p:spPr>
+          <a:xfrm>
+            <a:off x="640080" y="2880360"/>
+            <a:ext cx="3392424" cy="2468880"/>
+          </a:xfrm>
+          <a:prstGeom prst="roundRect">
+            <a:avLst>
+              <a:gd name="adj" fmla="val 4074"/>
+            </a:avLst>
+          </a:prstGeom>
+          <a:solidFill>
+            <a:srgbClr val="F4F8F6"/>
+          </a:solidFill>
+          <a:ln w="12700">
+            <a:solidFill>
+              <a:srgbClr val="D2DED9"/>
+            </a:solidFill>
+            <a:prstDash val="solid"/>
+          </a:ln>
+          <a:effectLst>
+            <a:outerShdw sx="100000" sy="100000" kx="0" ky="0" algn="bl" rotWithShape="0" blurRad="114300" dist="38100" dir="5400000">
+              <a:srgbClr val="10312B">
+                <a:alpha val="16000"/>
+              </a:srgbClr>
+            </a:outerShdw>
+          </a:effectLst>
+        </p:spPr>
+      </p:sp>
+      <p:sp>
+        <p:nvSpPr>
+          <p:cNvPr id="6" name="Text 4"/>
+          <p:cNvSpPr/>
+          <p:nvPr/>
+        </p:nvSpPr>
+        <p:spPr>
+          <a:xfrm>
+            <a:off x="914400" y="3172968"/>
+            <a:ext cx="2843784" cy="731520"/>
+          </a:xfrm>
+          <a:prstGeom prst="rect">
+            <a:avLst/>
+          </a:prstGeom>
+          <a:noFill/>
+          <a:ln/>
+        </p:spPr>
+        <p:txBody>
+          <a:bodyPr wrap="square" rtlCol="0" anchor="ctr"/>
+          <a:lstStyle/>
+          <a:p>
+            <a:pPr indent="0" marL="0">
+              <a:buNone/>
+            </a:pPr>
+            <a:r>
+              <a:rPr lang="en-US" sz="4000" b="1" dirty="0">
+                <a:solidFill>
+                  <a:srgbClr val="1C8D69"/>
+                </a:solidFill>
+                <a:latin typeface="Cambria" pitchFamily="34" charset="0"/>
+                <a:ea typeface="Cambria" pitchFamily="34" charset="-122"/>
+                <a:cs typeface="Cambria" pitchFamily="34" charset="-120"/>
+              </a:rPr>
+              <a:t>74%</a:t>
+            </a:r>
+            <a:endParaRPr lang="en-US" sz="4000" dirty="0"/>
+          </a:p>
+        </p:txBody>
+      </p:sp>
+      <p:sp>
+        <p:nvSpPr>
+          <p:cNvPr id="7" name="Text 5"/>
+          <p:cNvSpPr/>
+          <p:nvPr/>
+        </p:nvSpPr>
+        <p:spPr>
+          <a:xfrm>
+            <a:off x="914400" y="4023360"/>
+            <a:ext cx="2843784" cy="914400"/>
+          </a:xfrm>
+          <a:prstGeom prst="rect">
+            <a:avLst/>
+          </a:prstGeom>
+          <a:noFill/>
+          <a:ln/>
+        </p:spPr>
+        <p:txBody>
+          <a:bodyPr wrap="square" rtlCol="0" anchor="ctr"/>
+          <a:lstStyle/>
+          <a:p>
+            <a:pPr indent="0" marL="0">
+              <a:lnSpc>
+                <a:spcPct val="108000"/>
+              </a:lnSpc>
+              <a:buNone/>
+            </a:pPr>
+            <a:r>
+              <a:rPr lang="en-US" sz="1300" dirty="0">
+                <a:solidFill>
+                  <a:srgbClr val="12312F"/>
+                </a:solidFill>
+                <a:latin typeface="Calibri" pitchFamily="34" charset="0"/>
+                <a:ea typeface="Calibri" pitchFamily="34" charset="-122"/>
+                <a:cs typeface="Calibri" pitchFamily="34" charset="-120"/>
+              </a:rPr>
+              <a:t>are more effective at their job when they feel heard.</a:t>
+            </a:r>
+            <a:endParaRPr lang="en-US" sz="1300" dirty="0"/>
+          </a:p>
+        </p:txBody>
+      </p:sp>
+      <p:sp>
+        <p:nvSpPr>
+          <p:cNvPr id="8" name="Text 6"/>
+          <p:cNvSpPr/>
+          <p:nvPr/>
+        </p:nvSpPr>
+        <p:spPr>
+          <a:xfrm>
+            <a:off x="914400" y="4965192"/>
+            <a:ext cx="2843784" cy="274320"/>
+          </a:xfrm>
+          <a:prstGeom prst="rect">
+            <a:avLst/>
+          </a:prstGeom>
+          <a:noFill/>
+          <a:ln/>
+        </p:spPr>
+        <p:txBody>
+          <a:bodyPr wrap="square" rtlCol="0" anchor="ctr"/>
+          <a:lstStyle/>
+          <a:p>
+            <a:pPr indent="0" marL="0">
+              <a:buNone/>
+            </a:pPr>
+            <a:r>
+              <a:rPr lang="en-US" sz="1050" i="1" dirty="0">
+                <a:solidFill>
+                  <a:srgbClr val="5A716C"/>
+                </a:solidFill>
+                <a:latin typeface="Calibri" pitchFamily="34" charset="0"/>
+                <a:ea typeface="Calibri" pitchFamily="34" charset="-122"/>
+                <a:cs typeface="Calibri" pitchFamily="34" charset="-120"/>
+              </a:rPr>
+              <a:t>UKG Workforce Institute</a:t>
+            </a:r>
+            <a:endParaRPr lang="en-US" sz="1050" dirty="0"/>
+          </a:p>
+        </p:txBody>
+      </p:sp>
+      <p:sp>
+        <p:nvSpPr>
+          <p:cNvPr id="9" name="Shape 7"/>
+          <p:cNvSpPr/>
+          <p:nvPr/>
+        </p:nvSpPr>
+        <p:spPr>
+          <a:xfrm>
+            <a:off x="4398264" y="2880360"/>
+            <a:ext cx="3392424" cy="2468880"/>
+          </a:xfrm>
+          <a:prstGeom prst="roundRect">
+            <a:avLst>
+              <a:gd name="adj" fmla="val 4074"/>
+            </a:avLst>
+          </a:prstGeom>
+          <a:solidFill>
+            <a:srgbClr val="F4F8F6"/>
+          </a:solidFill>
+          <a:ln w="12700">
+            <a:solidFill>
+              <a:srgbClr val="D2DED9"/>
+            </a:solidFill>
+            <a:prstDash val="solid"/>
+          </a:ln>
+          <a:effectLst>
+            <a:outerShdw sx="100000" sy="100000" kx="0" ky="0" algn="bl" rotWithShape="0" blurRad="114300" dist="38100" dir="5400000">
+              <a:srgbClr val="10312B">
+                <a:alpha val="16000"/>
+              </a:srgbClr>
+            </a:outerShdw>
+          </a:effectLst>
+        </p:spPr>
+      </p:sp>
+      <p:sp>
+        <p:nvSpPr>
+          <p:cNvPr id="10" name="Text 8"/>
+          <p:cNvSpPr/>
+          <p:nvPr/>
+        </p:nvSpPr>
+        <p:spPr>
+          <a:xfrm>
+            <a:off x="4672584" y="3172968"/>
+            <a:ext cx="2843784" cy="731520"/>
+          </a:xfrm>
+          <a:prstGeom prst="rect">
+            <a:avLst/>
+          </a:prstGeom>
+          <a:noFill/>
+          <a:ln/>
+        </p:spPr>
+        <p:txBody>
+          <a:bodyPr wrap="square" rtlCol="0" anchor="ctr"/>
+          <a:lstStyle/>
+          <a:p>
+            <a:pPr indent="0" marL="0">
+              <a:buNone/>
+            </a:pPr>
+            <a:r>
+              <a:rPr lang="en-US" sz="4000" b="1" dirty="0">
+                <a:solidFill>
+                  <a:srgbClr val="1C8D69"/>
+                </a:solidFill>
+                <a:latin typeface="Cambria" pitchFamily="34" charset="0"/>
+                <a:ea typeface="Cambria" pitchFamily="34" charset="-122"/>
+                <a:cs typeface="Cambria" pitchFamily="34" charset="-120"/>
+              </a:rPr>
+              <a:t>10–15%</a:t>
+            </a:r>
+            <a:endParaRPr lang="en-US" sz="4000" dirty="0"/>
+          </a:p>
+        </p:txBody>
+      </p:sp>
+      <p:sp>
+        <p:nvSpPr>
+          <p:cNvPr id="11" name="Text 9"/>
+          <p:cNvSpPr/>
+          <p:nvPr/>
+        </p:nvSpPr>
+        <p:spPr>
+          <a:xfrm>
+            <a:off x="4672584" y="4023360"/>
+            <a:ext cx="2843784" cy="914400"/>
+          </a:xfrm>
+          <a:prstGeom prst="rect">
+            <a:avLst/>
+          </a:prstGeom>
+          <a:noFill/>
+          <a:ln/>
+        </p:spPr>
+        <p:txBody>
+          <a:bodyPr wrap="square" rtlCol="0" anchor="ctr"/>
+          <a:lstStyle/>
+          <a:p>
+            <a:pPr indent="0" marL="0">
+              <a:lnSpc>
+                <a:spcPct val="108000"/>
+              </a:lnSpc>
+              <a:buNone/>
+            </a:pPr>
+            <a:r>
+              <a:rPr lang="en-US" sz="1300" dirty="0">
+                <a:solidFill>
+                  <a:srgbClr val="12312F"/>
+                </a:solidFill>
+                <a:latin typeface="Calibri" pitchFamily="34" charset="0"/>
+                <a:ea typeface="Calibri" pitchFamily="34" charset="-122"/>
+                <a:cs typeface="Calibri" pitchFamily="34" charset="-120"/>
+              </a:rPr>
+              <a:t>of people are truly self-aware — though 95% think they are.</a:t>
+            </a:r>
+            <a:endParaRPr lang="en-US" sz="1300" dirty="0"/>
+          </a:p>
+        </p:txBody>
+      </p:sp>
+      <p:sp>
+        <p:nvSpPr>
+          <p:cNvPr id="12" name="Text 10"/>
+          <p:cNvSpPr/>
+          <p:nvPr/>
+        </p:nvSpPr>
+        <p:spPr>
+          <a:xfrm>
+            <a:off x="4672584" y="4965192"/>
+            <a:ext cx="2843784" cy="274320"/>
+          </a:xfrm>
+          <a:prstGeom prst="rect">
+            <a:avLst/>
+          </a:prstGeom>
+          <a:noFill/>
+          <a:ln/>
+        </p:spPr>
+        <p:txBody>
+          <a:bodyPr wrap="square" rtlCol="0" anchor="ctr"/>
+          <a:lstStyle/>
+          <a:p>
+            <a:pPr indent="0" marL="0">
+              <a:buNone/>
+            </a:pPr>
+            <a:r>
+              <a:rPr lang="en-US" sz="1050" i="1" dirty="0">
+                <a:solidFill>
+                  <a:srgbClr val="5A716C"/>
+                </a:solidFill>
+                <a:latin typeface="Calibri" pitchFamily="34" charset="0"/>
+                <a:ea typeface="Calibri" pitchFamily="34" charset="-122"/>
+                <a:cs typeface="Calibri" pitchFamily="34" charset="-120"/>
+              </a:rPr>
+              <a:t>T. Eurich, Harvard Business Review</a:t>
+            </a:r>
+            <a:endParaRPr lang="en-US" sz="1050" dirty="0"/>
+          </a:p>
+        </p:txBody>
+      </p:sp>
+      <p:sp>
+        <p:nvSpPr>
+          <p:cNvPr id="13" name="Shape 11"/>
+          <p:cNvSpPr/>
+          <p:nvPr/>
+        </p:nvSpPr>
+        <p:spPr>
+          <a:xfrm>
+            <a:off x="8156448" y="2880360"/>
+            <a:ext cx="3392424" cy="2468880"/>
+          </a:xfrm>
+          <a:prstGeom prst="roundRect">
+            <a:avLst>
+              <a:gd name="adj" fmla="val 4074"/>
+            </a:avLst>
+          </a:prstGeom>
+          <a:solidFill>
+            <a:srgbClr val="F4F8F6"/>
+          </a:solidFill>
+          <a:ln w="12700">
+            <a:solidFill>
+              <a:srgbClr val="D2DED9"/>
+            </a:solidFill>
+            <a:prstDash val="solid"/>
+          </a:ln>
+          <a:effectLst>
+            <a:outerShdw sx="100000" sy="100000" kx="0" ky="0" algn="bl" rotWithShape="0" blurRad="114300" dist="38100" dir="5400000">
+              <a:srgbClr val="10312B">
+                <a:alpha val="16000"/>
+              </a:srgbClr>
+            </a:outerShdw>
+          </a:effectLst>
+        </p:spPr>
+      </p:sp>
+      <p:sp>
+        <p:nvSpPr>
+          <p:cNvPr id="14" name="Text 12"/>
+          <p:cNvSpPr/>
+          <p:nvPr/>
+        </p:nvSpPr>
+        <p:spPr>
+          <a:xfrm>
+            <a:off x="8430768" y="3172968"/>
+            <a:ext cx="2843784" cy="731520"/>
+          </a:xfrm>
+          <a:prstGeom prst="rect">
+            <a:avLst/>
+          </a:prstGeom>
+          <a:noFill/>
+          <a:ln/>
+        </p:spPr>
+        <p:txBody>
+          <a:bodyPr wrap="square" rtlCol="0" anchor="ctr"/>
+          <a:lstStyle/>
+          <a:p>
+            <a:pPr indent="0" marL="0">
+              <a:buNone/>
+            </a:pPr>
+            <a:r>
+              <a:rPr lang="en-US" sz="4000" b="1" dirty="0">
+                <a:solidFill>
+                  <a:srgbClr val="1C8D69"/>
+                </a:solidFill>
+                <a:latin typeface="Cambria" pitchFamily="34" charset="0"/>
+                <a:ea typeface="Cambria" pitchFamily="34" charset="-122"/>
+                <a:cs typeface="Cambria" pitchFamily="34" charset="-120"/>
+              </a:rPr>
+              <a:t>4.6×</a:t>
+            </a:r>
+            <a:endParaRPr lang="en-US" sz="4000" dirty="0"/>
+          </a:p>
+        </p:txBody>
+      </p:sp>
+      <p:sp>
+        <p:nvSpPr>
+          <p:cNvPr id="15" name="Text 13"/>
+          <p:cNvSpPr/>
+          <p:nvPr/>
+        </p:nvSpPr>
+        <p:spPr>
+          <a:xfrm>
+            <a:off x="8430768" y="4023360"/>
+            <a:ext cx="2843784" cy="914400"/>
+          </a:xfrm>
+          <a:prstGeom prst="rect">
+            <a:avLst/>
+          </a:prstGeom>
+          <a:noFill/>
+          <a:ln/>
+        </p:spPr>
+        <p:txBody>
+          <a:bodyPr wrap="square" rtlCol="0" anchor="ctr"/>
+          <a:lstStyle/>
+          <a:p>
+            <a:pPr indent="0" marL="0">
+              <a:lnSpc>
+                <a:spcPct val="108000"/>
+              </a:lnSpc>
+              <a:buNone/>
+            </a:pPr>
+            <a:r>
+              <a:rPr lang="en-US" sz="1300" dirty="0">
+                <a:solidFill>
+                  <a:srgbClr val="12312F"/>
+                </a:solidFill>
+                <a:latin typeface="Calibri" pitchFamily="34" charset="0"/>
+                <a:ea typeface="Calibri" pitchFamily="34" charset="-122"/>
+                <a:cs typeface="Calibri" pitchFamily="34" charset="-120"/>
+              </a:rPr>
+              <a:t>more likely to do their best work when they feel their voice is heard.</a:t>
+            </a:r>
+            <a:endParaRPr lang="en-US" sz="1300" dirty="0"/>
+          </a:p>
+        </p:txBody>
+      </p:sp>
+      <p:sp>
+        <p:nvSpPr>
+          <p:cNvPr id="16" name="Text 14"/>
+          <p:cNvSpPr/>
+          <p:nvPr/>
+        </p:nvSpPr>
+        <p:spPr>
+          <a:xfrm>
+            <a:off x="8430768" y="4965192"/>
+            <a:ext cx="2843784" cy="274320"/>
+          </a:xfrm>
+          <a:prstGeom prst="rect">
+            <a:avLst/>
+          </a:prstGeom>
+          <a:noFill/>
+          <a:ln/>
+        </p:spPr>
+        <p:txBody>
+          <a:bodyPr wrap="square" rtlCol="0" anchor="ctr"/>
+          <a:lstStyle/>
+          <a:p>
+            <a:pPr indent="0" marL="0">
+              <a:buNone/>
+            </a:pPr>
+            <a:r>
+              <a:rPr lang="en-US" sz="1050" i="1" dirty="0">
+                <a:solidFill>
+                  <a:srgbClr val="5A716C"/>
+                </a:solidFill>
+                <a:latin typeface="Calibri" pitchFamily="34" charset="0"/>
+                <a:ea typeface="Calibri" pitchFamily="34" charset="-122"/>
+                <a:cs typeface="Calibri" pitchFamily="34" charset="-120"/>
+              </a:rPr>
+              <a:t>Salesforce Research</a:t>
+            </a:r>
+            <a:endParaRPr lang="en-US" sz="1050" dirty="0"/>
+          </a:p>
+        </p:txBody>
+      </p:sp>
+      <p:sp>
+        <p:nvSpPr>
+          <p:cNvPr id="17" name="Text 15"/>
+          <p:cNvSpPr/>
+          <p:nvPr/>
+        </p:nvSpPr>
+        <p:spPr>
+          <a:xfrm>
+            <a:off x="640080" y="5577840"/>
+            <a:ext cx="10908792" cy="457200"/>
+          </a:xfrm>
+          <a:prstGeom prst="rect">
+            <a:avLst/>
+          </a:prstGeom>
+          <a:noFill/>
+          <a:ln/>
+        </p:spPr>
+        <p:txBody>
+          <a:bodyPr wrap="square" rtlCol="0" anchor="ctr"/>
+          <a:lstStyle/>
+          <a:p>
+            <a:pPr indent="0" marL="0">
+              <a:buNone/>
+            </a:pPr>
+            <a:r>
+              <a:rPr lang="en-US" sz="1300" i="1" dirty="0">
+                <a:solidFill>
+                  <a:srgbClr val="5A716C"/>
+                </a:solidFill>
+                <a:latin typeface="Calibri" pitchFamily="34" charset="0"/>
+                <a:ea typeface="Calibri" pitchFamily="34" charset="-122"/>
+                <a:cs typeface="Calibri" pitchFamily="34" charset="-120"/>
+              </a:rPr>
+              <a:t>The market feels unheard and can’t see itself — exactly the gap SugApp is built for. Our own conversations confirm the demand.</a:t>
+            </a:r>
+            <a:endParaRPr lang="en-US" sz="1300" dirty="0"/>
+          </a:p>
+        </p:txBody>
+      </p:sp>
+    </p:spTree>
+  </p:cSld>
+  <p:clrMapOvr>
+    <a:masterClrMapping/>
+  </p:clrMapOvr>
+</p:sld>
+</file>
+
+<file path=ppt/slides/slide14.xml><?xml version="1.0" encoding="utf-8"?>
+<p:sld xmlns:a="http://schemas.openxmlformats.org/drawingml/2006/main" xmlns:r="http://schemas.openxmlformats.org/officeDocument/2006/relationships" xmlns:p="http://schemas.openxmlformats.org/presentationml/2006/main">
+  <p:cSld name="Slide 14">
+    <p:bg>
+      <p:bgPr>
+        <a:solidFill>
+          <a:srgbClr val="FFFFFF"/>
+        </a:solidFill>
+      </p:bgPr>
+    </p:bg>
+    <p:spTree>
+      <p:nvGrpSpPr>
+        <p:cNvPr id="1" name=""/>
+        <p:cNvGrpSpPr/>
+        <p:nvPr/>
+      </p:nvGrpSpPr>
+      <p:grpSpPr>
+        <a:xfrm>
+          <a:off x="0" y="0"/>
+          <a:ext cx="0" cy="0"/>
+          <a:chOff x="0" y="0"/>
+          <a:chExt cx="0" cy="0"/>
+        </a:xfrm>
+      </p:grpSpPr>
+      <p:sp>
+        <p:nvSpPr>
+          <p:cNvPr id="2" name="Text 0"/>
+          <p:cNvSpPr/>
+          <p:nvPr/>
+        </p:nvSpPr>
+        <p:spPr>
+          <a:xfrm>
+            <a:off x="640080" y="502920"/>
+            <a:ext cx="10908792" cy="274320"/>
+          </a:xfrm>
+          <a:prstGeom prst="rect">
+            <a:avLst/>
+          </a:prstGeom>
+          <a:noFill/>
+          <a:ln/>
+        </p:spPr>
+        <p:txBody>
+          <a:bodyPr wrap="square" rtlCol="0" anchor="ctr"/>
+          <a:lstStyle/>
+          <a:p>
+            <a:pPr algn="l" indent="0" marL="0">
+              <a:buNone/>
+            </a:pPr>
+            <a:r>
+              <a:rPr lang="en-US" sz="1150" b="1" spc="300" kern="0" dirty="0">
+                <a:solidFill>
+                  <a:srgbClr val="1C8D69"/>
+                </a:solidFill>
+                <a:latin typeface="Calibri" pitchFamily="34" charset="0"/>
+                <a:ea typeface="Calibri" pitchFamily="34" charset="-122"/>
+                <a:cs typeface="Calibri" pitchFamily="34" charset="-120"/>
+              </a:rPr>
+              <a:t>13 · FOUNDER</a:t>
+            </a:r>
+            <a:endParaRPr lang="en-US" sz="1150" dirty="0"/>
+          </a:p>
+        </p:txBody>
+      </p:sp>
+      <p:sp>
+        <p:nvSpPr>
+          <p:cNvPr id="3" name="Text 1"/>
+          <p:cNvSpPr/>
+          <p:nvPr/>
+        </p:nvSpPr>
+        <p:spPr>
+          <a:xfrm>
+            <a:off x="640080" y="841248"/>
+            <a:ext cx="10908792" cy="914400"/>
+          </a:xfrm>
+          <a:prstGeom prst="rect">
+            <a:avLst/>
+          </a:prstGeom>
+          <a:noFill/>
+          <a:ln/>
+        </p:spPr>
+        <p:txBody>
+          <a:bodyPr wrap="square" rtlCol="0" anchor="ctr"/>
+          <a:lstStyle/>
+          <a:p>
+            <a:pPr algn="l" indent="0" marL="0">
+              <a:lnSpc>
+                <a:spcPct val="98000"/>
+              </a:lnSpc>
+              <a:buNone/>
+            </a:pPr>
+            <a:r>
+              <a:rPr lang="en-US" sz="3300" b="1" dirty="0">
+                <a:solidFill>
+                  <a:srgbClr val="12312F"/>
+                </a:solidFill>
+                <a:latin typeface="Cambria" pitchFamily="34" charset="0"/>
+                <a:ea typeface="Cambria" pitchFamily="34" charset="-122"/>
+                <a:cs typeface="Cambria" pitchFamily="34" charset="-120"/>
+              </a:rPr>
+              <a:t>Built from twenty years inside the problem.</a:t>
+            </a:r>
+            <a:endParaRPr lang="en-US" sz="3300" dirty="0"/>
+          </a:p>
+        </p:txBody>
+      </p:sp>
+      <p:sp>
+        <p:nvSpPr>
+          <p:cNvPr id="4" name="Text 2"/>
+          <p:cNvSpPr/>
+          <p:nvPr/>
+        </p:nvSpPr>
+        <p:spPr>
+          <a:xfrm>
+            <a:off x="640080" y="1783080"/>
+            <a:ext cx="10908792" cy="822960"/>
+          </a:xfrm>
+          <a:prstGeom prst="rect">
+            <a:avLst/>
+          </a:prstGeom>
+          <a:noFill/>
+          <a:ln/>
+        </p:spPr>
+        <p:txBody>
+          <a:bodyPr wrap="square" rtlCol="0" anchor="ctr"/>
+          <a:lstStyle/>
+          <a:p>
+            <a:pPr indent="0" marL="0">
+              <a:lnSpc>
+                <a:spcPct val="112000"/>
+              </a:lnSpc>
+              <a:buNone/>
+            </a:pPr>
+            <a:r>
+              <a:rPr lang="en-US" sz="1500" b="1" dirty="0">
+                <a:solidFill>
+                  <a:srgbClr val="12312F"/>
+                </a:solidFill>
+                <a:latin typeface="Calibri" pitchFamily="34" charset="0"/>
+                <a:ea typeface="Calibri" pitchFamily="34" charset="-122"/>
+                <a:cs typeface="Calibri" pitchFamily="34" charset="-120"/>
+              </a:rPr>
+              <a:t>Suguna Mannepalli</a:t>
+            </a:r>
+            <a:pPr indent="0" marL="0">
+              <a:lnSpc>
+                <a:spcPct val="112000"/>
+              </a:lnSpc>
+              <a:buNone/>
+            </a:pPr>
+            <a:r>
+              <a:rPr lang="en-US" sz="1500" dirty="0">
+                <a:solidFill>
+                  <a:srgbClr val="12312F"/>
+                </a:solidFill>
+                <a:latin typeface="Calibri" pitchFamily="34" charset="0"/>
+                <a:ea typeface="Calibri" pitchFamily="34" charset="-122"/>
+                <a:cs typeface="Calibri" pitchFamily="34" charset="-120"/>
+              </a:rPr>
+              <a:t> — 20+ years leading teams in corporate IT, and an accredited leadership coach (Association for Coaching). SugApp comes from both chairs: the operator who watched culture break, and the coach who helps people change.</a:t>
+            </a:r>
+            <a:endParaRPr lang="en-US" sz="1500" dirty="0"/>
+          </a:p>
+        </p:txBody>
+      </p:sp>
+      <p:sp>
+        <p:nvSpPr>
+          <p:cNvPr id="5" name="Shape 3"/>
+          <p:cNvSpPr/>
+          <p:nvPr/>
+        </p:nvSpPr>
+        <p:spPr>
+          <a:xfrm>
+            <a:off x="640080" y="2926080"/>
+            <a:ext cx="5349240" cy="2286000"/>
+          </a:xfrm>
+          <a:prstGeom prst="roundRect">
+            <a:avLst>
+              <a:gd name="adj" fmla="val 4400"/>
+            </a:avLst>
+          </a:prstGeom>
+          <a:solidFill>
+            <a:srgbClr val="F4F8F6"/>
+          </a:solidFill>
+          <a:ln w="12700">
+            <a:solidFill>
+              <a:srgbClr val="D2DED9"/>
+            </a:solidFill>
+            <a:prstDash val="solid"/>
+          </a:ln>
+          <a:effectLst>
+            <a:outerShdw sx="100000" sy="100000" kx="0" ky="0" algn="bl" rotWithShape="0" blurRad="114300" dist="38100" dir="5400000">
+              <a:srgbClr val="10312B">
+                <a:alpha val="16000"/>
+              </a:srgbClr>
+            </a:outerShdw>
+          </a:effectLst>
+        </p:spPr>
+      </p:sp>
+      <p:sp>
+        <p:nvSpPr>
+          <p:cNvPr id="6" name="Text 4"/>
+          <p:cNvSpPr/>
+          <p:nvPr/>
+        </p:nvSpPr>
+        <p:spPr>
+          <a:xfrm>
+            <a:off x="960120" y="3182112"/>
+            <a:ext cx="4709160" cy="365760"/>
+          </a:xfrm>
+          <a:prstGeom prst="rect">
+            <a:avLst/>
+          </a:prstGeom>
+          <a:noFill/>
+          <a:ln/>
+        </p:spPr>
+        <p:txBody>
+          <a:bodyPr wrap="square" rtlCol="0" anchor="ctr"/>
+          <a:lstStyle/>
+          <a:p>
+            <a:pPr indent="0" marL="0">
+              <a:buNone/>
+            </a:pPr>
+            <a:r>
+              <a:rPr lang="en-US" sz="1600" b="1" dirty="0">
+                <a:solidFill>
+                  <a:srgbClr val="B5503F"/>
+                </a:solidFill>
+                <a:latin typeface="Calibri" pitchFamily="34" charset="0"/>
+                <a:ea typeface="Calibri" pitchFamily="34" charset="-122"/>
+                <a:cs typeface="Calibri" pitchFamily="34" charset="-120"/>
+              </a:rPr>
+              <a:t>What I kept seeing</a:t>
+            </a:r>
+            <a:endParaRPr lang="en-US" sz="1600" dirty="0"/>
+          </a:p>
+        </p:txBody>
+      </p:sp>
+      <p:sp>
+        <p:nvSpPr>
+          <p:cNvPr id="7" name="Text 5"/>
+          <p:cNvSpPr/>
+          <p:nvPr/>
+        </p:nvSpPr>
+        <p:spPr>
+          <a:xfrm>
+            <a:off x="960120" y="3703320"/>
+            <a:ext cx="4709160" cy="1371600"/>
+          </a:xfrm>
+          <a:prstGeom prst="rect">
+            <a:avLst/>
+          </a:prstGeom>
+          <a:noFill/>
+          <a:ln/>
+        </p:spPr>
+        <p:txBody>
+          <a:bodyPr wrap="square" rtlCol="0" anchor="ctr"/>
+          <a:lstStyle/>
+          <a:p>
+            <a:pPr indent="0" marL="0">
+              <a:lnSpc>
+                <a:spcPct val="108000"/>
+              </a:lnSpc>
+              <a:buNone/>
+            </a:pPr>
+            <a:r>
+              <a:rPr lang="en-US" sz="1350" dirty="0">
+                <a:solidFill>
+                  <a:srgbClr val="12312F"/>
+                </a:solidFill>
+                <a:latin typeface="Calibri" pitchFamily="34" charset="0"/>
+                <a:ea typeface="Calibri" pitchFamily="34" charset="-122"/>
+                <a:cs typeface="Calibri" pitchFamily="34" charset="-120"/>
+              </a:rPr>
+              <a:t>The loudest voice gets mistaken for the most knowledgeable. Hierarchy quietly overrides better judgment. People in power rarely get to see their own behavior — while the teams beneath them are scrutinized for echoing it.</a:t>
+            </a:r>
+            <a:endParaRPr lang="en-US" sz="1350" dirty="0"/>
+          </a:p>
+        </p:txBody>
+      </p:sp>
+      <p:sp>
+        <p:nvSpPr>
+          <p:cNvPr id="8" name="Shape 6"/>
+          <p:cNvSpPr/>
+          <p:nvPr/>
+        </p:nvSpPr>
+        <p:spPr>
+          <a:xfrm>
+            <a:off x="6199632" y="2926080"/>
+            <a:ext cx="5349240" cy="2286000"/>
+          </a:xfrm>
+          <a:prstGeom prst="roundRect">
+            <a:avLst>
+              <a:gd name="adj" fmla="val 4400"/>
+            </a:avLst>
+          </a:prstGeom>
+          <a:solidFill>
+            <a:srgbClr val="FFFFFF"/>
+          </a:solidFill>
+          <a:ln w="12700">
+            <a:solidFill>
+              <a:srgbClr val="D2DED9"/>
+            </a:solidFill>
+            <a:prstDash val="solid"/>
+          </a:ln>
+          <a:effectLst>
+            <a:outerShdw sx="100000" sy="100000" kx="0" ky="0" algn="bl" rotWithShape="0" blurRad="114300" dist="38100" dir="5400000">
+              <a:srgbClr val="10312B">
+                <a:alpha val="16000"/>
+              </a:srgbClr>
+            </a:outerShdw>
+          </a:effectLst>
+        </p:spPr>
+      </p:sp>
+      <p:sp>
+        <p:nvSpPr>
+          <p:cNvPr id="9" name="Text 7"/>
+          <p:cNvSpPr/>
+          <p:nvPr/>
+        </p:nvSpPr>
+        <p:spPr>
+          <a:xfrm>
+            <a:off x="6519672" y="3182112"/>
+            <a:ext cx="4709160" cy="365760"/>
+          </a:xfrm>
+          <a:prstGeom prst="rect">
+            <a:avLst/>
+          </a:prstGeom>
+          <a:noFill/>
+          <a:ln/>
+        </p:spPr>
+        <p:txBody>
+          <a:bodyPr wrap="square" rtlCol="0" anchor="ctr"/>
+          <a:lstStyle/>
+          <a:p>
+            <a:pPr indent="0" marL="0">
+              <a:buNone/>
+            </a:pPr>
+            <a:r>
+              <a:rPr lang="en-US" sz="1600" b="1" dirty="0">
+                <a:solidFill>
+                  <a:srgbClr val="1C8D69"/>
+                </a:solidFill>
+                <a:latin typeface="Calibri" pitchFamily="34" charset="0"/>
+                <a:ea typeface="Calibri" pitchFamily="34" charset="-122"/>
+                <a:cs typeface="Calibri" pitchFamily="34" charset="-120"/>
+              </a:rPr>
+              <a:t>What actually changes people</a:t>
+            </a:r>
+            <a:endParaRPr lang="en-US" sz="1600" dirty="0"/>
+          </a:p>
+        </p:txBody>
+      </p:sp>
+      <p:sp>
+        <p:nvSpPr>
+          <p:cNvPr id="10" name="Text 8"/>
+          <p:cNvSpPr/>
+          <p:nvPr/>
+        </p:nvSpPr>
+        <p:spPr>
+          <a:xfrm>
+            <a:off x="6519672" y="3703320"/>
+            <a:ext cx="4709160" cy="1371600"/>
+          </a:xfrm>
+          <a:prstGeom prst="rect">
+            <a:avLst/>
+          </a:prstGeom>
+          <a:noFill/>
+          <a:ln/>
+        </p:spPr>
+        <p:txBody>
+          <a:bodyPr wrap="square" rtlCol="0" anchor="ctr"/>
+          <a:lstStyle/>
+          <a:p>
+            <a:pPr indent="0" marL="0">
+              <a:lnSpc>
+                <a:spcPct val="108000"/>
+              </a:lnSpc>
+              <a:buNone/>
+            </a:pPr>
+            <a:r>
+              <a:rPr lang="en-US" sz="1350" dirty="0">
+                <a:solidFill>
+                  <a:srgbClr val="12312F"/>
+                </a:solidFill>
+                <a:latin typeface="Calibri" pitchFamily="34" charset="0"/>
+                <a:ea typeface="Calibri" pitchFamily="34" charset="-122"/>
+                <a:cs typeface="Calibri" pitchFamily="34" charset="-120"/>
+              </a:rPr>
+              <a:t>Told to change, people get defensive. </a:t>
+            </a:r>
+            <a:pPr indent="0" marL="0">
+              <a:lnSpc>
+                <a:spcPct val="108000"/>
+              </a:lnSpc>
+              <a:buNone/>
+            </a:pPr>
+            <a:r>
+              <a:rPr lang="en-US" sz="1350" b="1" dirty="0">
+                <a:solidFill>
+                  <a:srgbClr val="12312F"/>
+                </a:solidFill>
+                <a:latin typeface="Calibri" pitchFamily="34" charset="0"/>
+                <a:ea typeface="Calibri" pitchFamily="34" charset="-122"/>
+                <a:cs typeface="Calibri" pitchFamily="34" charset="-120"/>
+              </a:rPr>
+              <a:t>Heard</a:t>
+            </a:r>
+            <a:pPr indent="0" marL="0">
+              <a:lnSpc>
+                <a:spcPct val="108000"/>
+              </a:lnSpc>
+              <a:buNone/>
+            </a:pPr>
+            <a:r>
+              <a:rPr lang="en-US" sz="1350" dirty="0">
+                <a:solidFill>
+                  <a:srgbClr val="12312F"/>
+                </a:solidFill>
+                <a:latin typeface="Calibri" pitchFamily="34" charset="0"/>
+                <a:ea typeface="Calibri" pitchFamily="34" charset="-122"/>
+                <a:cs typeface="Calibri" pitchFamily="34" charset="-120"/>
+              </a:rPr>
+              <a:t>, and given room to reflect, they improve on their own — and outperform. The lost skill of our moment isn’t communication — it’s listening.</a:t>
+            </a:r>
+            <a:endParaRPr lang="en-US" sz="1350" dirty="0"/>
+          </a:p>
+        </p:txBody>
+      </p:sp>
+      <p:sp>
+        <p:nvSpPr>
+          <p:cNvPr id="11" name="Text 9"/>
+          <p:cNvSpPr/>
+          <p:nvPr/>
+        </p:nvSpPr>
+        <p:spPr>
+          <a:xfrm>
+            <a:off x="640080" y="5486400"/>
+            <a:ext cx="10908792" cy="548640"/>
+          </a:xfrm>
+          <a:prstGeom prst="rect">
+            <a:avLst/>
+          </a:prstGeom>
+          <a:noFill/>
+          <a:ln/>
+        </p:spPr>
+        <p:txBody>
+          <a:bodyPr wrap="square" rtlCol="0" anchor="ctr"/>
+          <a:lstStyle/>
+          <a:p>
+            <a:pPr indent="0" marL="0">
+              <a:buNone/>
+            </a:pPr>
+            <a:r>
+              <a:rPr lang="en-US" sz="1600" i="1" dirty="0">
+                <a:solidFill>
+                  <a:srgbClr val="12312F"/>
+                </a:solidFill>
+                <a:latin typeface="Cambria" pitchFamily="34" charset="0"/>
+                <a:ea typeface="Cambria" pitchFamily="34" charset="-122"/>
+                <a:cs typeface="Cambria" pitchFamily="34" charset="-120"/>
+              </a:rPr>
+              <a:t>SugApp productizes that coaching truth: a private mirror for self-reflection, never a manager’s verdict.</a:t>
+            </a:r>
+            <a:endParaRPr lang="en-US" sz="1600" dirty="0"/>
+          </a:p>
+        </p:txBody>
+      </p:sp>
+    </p:spTree>
+  </p:cSld>
+  <p:clrMapOvr>
+    <a:masterClrMapping/>
+  </p:clrMapOvr>
+</p:sld>
+</file>
+
+<file path=ppt/slides/slide15.xml><?xml version="1.0" encoding="utf-8"?>
+<p:sld xmlns:a="http://schemas.openxmlformats.org/drawingml/2006/main" xmlns:r="http://schemas.openxmlformats.org/officeDocument/2006/relationships" xmlns:p="http://schemas.openxmlformats.org/presentationml/2006/main">
+  <p:cSld name="Slide 15">
+    <p:bg>
+      <p:bgPr>
+        <a:solidFill>
           <a:srgbClr val="0F2A2E"/>
         </a:solidFill>
       </p:bgPr>
@@ -4963,7 +6272,7 @@
                 <a:ea typeface="Calibri" pitchFamily="34" charset="-122"/>
                 <a:cs typeface="Calibri" pitchFamily="34" charset="-120"/>
               </a:rPr>
-              <a:t>12 · THE ASK</a:t>
+              <a:t>14 · THE ASK</a:t>
             </a:r>
             <a:endParaRPr lang="en-US" sz="1150" dirty="0"/>
           </a:p>

</xml_diff>